<commit_message>
Expand Week 2 notebook with detailed comments, explanations, and neuropharmacology section
- Add detailed comments above every line of code in all code cells
- Expand all markdown cells with thorough background explanations
- Add SMILES history and syntax rules, Morgan/ECFP algorithm details,
  QSAR history (Hansch & Fujita 1964), Random Forest and XGBoost theory
- Add new Neuropharmacology Connection section with dose-response curves,
  Hill equation simulation, curve fitting, and pIC50 connection to QSAR
- Expand references section with historical and pharmacology citations

Co-authored-by: Copilot <223556219+Copilot@users.noreply.github.com>

Co-authored-by: ETigerschuss <3415055+ETigerschuss@users.noreply.github.com>
</commit_message>
<xml_diff>
--- a/week1_introduction/slides.pptx
+++ b/week1_introduction/slides.pptx
@@ -941,7 +941,243 @@
           <a:lstStyle/>
           <a:p>
             <a:r>
-              <a:t>Spend 4-5 minutes here. This is a unique connection point. If you have a SpikerBox, this is the moment for a live demo. Show a spike train recording: voltage trace over time, with action potentials. Then show a dose-response curve: drug concentration vs. biological response. Both are SIGNAL to FEATURES to MODEL problems. The SpikerBox was developed by Backyard Brains (backyardbrains.com). Marzullo et al. 2012 published the original educational paper. Ion channel drugs include: local anesthetics (sodium channel blockers), anti-epileptics. hERG channel toxicity (cardiac risk) is one of the most common reasons drugs fail.</a:t>
+              <a:t>DETAILED PRESENTER NOTES - BIOPHYSICAL MODELLING &amp; SPIKERBOT</a:t>
+            </a:r>
+          </a:p>
+          <a:p/>
+          <a:p>
+            <a:r>
+              <a:t>Spend 5-7 minutes on this slide. This is a unique hands-on connection between neuroscience and drug discovery.</a:t>
+            </a:r>
+          </a:p>
+          <a:p/>
+          <a:p>
+            <a:r>
+              <a:t>=== THE SPIKERBOT ===</a:t>
+            </a:r>
+          </a:p>
+          <a:p>
+            <a:r>
+              <a:t>The SpikerBot is made by Backyard Brains (backyardbrains.com). It is an open-source neuroscience education platform that can both RECORD and STIMULATE neural signals. The original SpikerBox paper is Marzullo &amp; Gage (2012), Advances in Physiology Education 36:2-14. The SpikerBot extends this with programmable stimulation and a robotic gripper controlled by neural signals.</a:t>
+            </a:r>
+          </a:p>
+          <a:p/>
+          <a:p>
+            <a:r>
+              <a:t>Key hardware components:</a:t>
+            </a:r>
+          </a:p>
+          <a:p>
+            <a:r>
+              <a:t>- Electrodes that interface with biological tissue (cockroach leg, earthworm, or human EMG)</a:t>
+            </a:r>
+          </a:p>
+          <a:p>
+            <a:r>
+              <a:t>- Amplifier that boosts microvolt signals to measurable range</a:t>
+            </a:r>
+          </a:p>
+          <a:p>
+            <a:r>
+              <a:t>- ADC (analog-to-digital converter) that digitizes the signal</a:t>
+            </a:r>
+          </a:p>
+          <a:p>
+            <a:r>
+              <a:t>- Microcontroller (Arduino-compatible) for programmable stimulation</a:t>
+            </a:r>
+          </a:p>
+          <a:p>
+            <a:r>
+              <a:t>- Software: Spike Recorder app for visualization and analysis</a:t>
+            </a:r>
+          </a:p>
+          <a:p/>
+          <a:p>
+            <a:r>
+              <a:t>=== PROGRAMMABLE NEURAL MOTIFS ===</a:t>
+            </a:r>
+          </a:p>
+          <a:p>
+            <a:r>
+              <a:t>The SpikerBot can be programmed to deliver different electrical stimulation patterns, and you can observe the neural response in real-time:</a:t>
+            </a:r>
+          </a:p>
+          <a:p/>
+          <a:p>
+            <a:r>
+              <a:t>1. TONIC FIRING: Regular, evenly-spaced action potentials. This is what you see in motor neurons during sustained muscle contraction, or in cardiac pacemaker cells. On the SpikerBot, program this as a constant-frequency pulse train (e.g., 10 Hz = one pulse every 100 ms). Students should observe that increasing stimulation frequency increases muscle contraction force (temporal summation).</a:t>
+            </a:r>
+          </a:p>
+          <a:p/>
+          <a:p>
+            <a:r>
+              <a:t>2. BURST FIRING: Clusters of rapid spikes separated by silent periods. This is characteristic of thalamocortical relay neurons (involved in sleep spindles and absence seizures), dopaminergic neurons in the VTA (reward signaling), and hippocampal place cells. On the SpikerBot, program this as 3-5 rapid pulses at 50-100 Hz, then a 200-500 ms pause, then repeat. Burst firing is more effective at triggering synaptic plasticity than tonic firing at the same average rate.</a:t>
+            </a:r>
+          </a:p>
+          <a:p/>
+          <a:p>
+            <a:r>
+              <a:t>3. IRREGULAR / POISSON FIRING: Random inter-spike intervals following an exponential distribution. This is the dominant pattern in cortical neurons during wakefulness. On the SpikerBot, program this with randomized inter-pulse intervals drawn from an exponential distribution with a given mean rate. Students should compare the muscle response to irregular vs. regular stimulation at the same average rate.</a:t>
+            </a:r>
+          </a:p>
+          <a:p/>
+          <a:p>
+            <a:r>
+              <a:t>=== NEUROPHARMACOLOGY ===</a:t>
+            </a:r>
+          </a:p>
+          <a:p>
+            <a:r>
+              <a:t>This is where the SpikerBot connects directly to drug discovery:</a:t>
+            </a:r>
+          </a:p>
+          <a:p/>
+          <a:p>
+            <a:r>
+              <a:t>Ion channels are transmembrane proteins that allow ions (Na+, K+, Ca2+, Cl-) to flow across cell membranes. They are essential for ALL electrical signaling in the body: neurons, muscles, heart. About 18% of all FDA-approved drugs target ion channels (Santos et al. 2017, Nature Reviews Drug Discovery 16:19-34).</a:t>
+            </a:r>
+          </a:p>
+          <a:p/>
+          <a:p>
+            <a:r>
+              <a:t>Key ion channel drug targets:</a:t>
+            </a:r>
+          </a:p>
+          <a:p>
+            <a:r>
+              <a:t>- Voltage-gated Na+ channels (Nav): Targeted by local anesthetics (lidocaine, bupivacaine), anti-epileptics (carbamazepine, phenytoin, lamotrigine), and some analgesics. These drugs block the channel pore, preventing Na+ influx and thus preventing action potentials. With the SpikerBot, applying lidocaine to a cockroach leg preparation will reduce/abolish action potentials in real-time.</a:t>
+            </a:r>
+          </a:p>
+          <a:p/>
+          <a:p>
+            <a:r>
+              <a:t>- Voltage-gated K+ channels (Kv): The hERG channel (Kv11.1, encoded by KCNH2 gene) is the SINGLE MOST IMPORTANT safety target in all of drug development. Blocking hERG causes QT interval prolongation on the ECG, which can lead to a lethal cardiac arrhythmia called Torsades de Pointes. Multiple drugs have been withdrawn from the market for hERG liability: terfenadine (Seldane), cisapride (Propulsid), astemizole. Today, hERG screening is MANDATORY for all drug candidates (ICH S7B guideline). ML models for hERG prediction are a hot research area.</a:t>
+            </a:r>
+          </a:p>
+          <a:p/>
+          <a:p>
+            <a:r>
+              <a:t>- Voltage-gated Ca2+ channels (Cav): Targeted by anti-hypertensives (amlodipine, nifedipine - L-type blockers), anti-epileptics (ethosuximide - T-type blockers), and pain drugs (gabapentin targets alpha-2-delta subunit).</a:t>
+            </a:r>
+          </a:p>
+          <a:p/>
+          <a:p>
+            <a:r>
+              <a:t>- Ligand-gated channels: GABA-A receptor (Cl- channel) targeted by benzodiazepines (diazepam, lorazepam) and barbiturates. Nicotinic acetylcholine receptor (Na+/K+ channel) targeted by smoking cessation drug varenicline (Chantix). NMDA receptor (Ca2+ channel) targeted by anesthetic ketamine and Alzheimer's drug memantine.</a:t>
+            </a:r>
+          </a:p>
+          <a:p/>
+          <a:p>
+            <a:r>
+              <a:t>=== THE HODGKIN-HUXLEY MODEL (1952) ===</a:t>
+            </a:r>
+          </a:p>
+          <a:p>
+            <a:r>
+              <a:t>Alan Hodgkin and Andrew Huxley published their mathematical model of the action potential in 1952 (Journal of Physiology 117:500-544), for which they won the 1963 Nobel Prize in Physiology or Medicine. This is THE foundational biophysical model.</a:t>
+            </a:r>
+          </a:p>
+          <a:p/>
+          <a:p>
+            <a:r>
+              <a:t>The model describes the membrane potential V as:</a:t>
+            </a:r>
+          </a:p>
+          <a:p>
+            <a:r>
+              <a:t>  C_m * dV/dt = -g_Na * m^3 * h * (V - E_Na) - g_K * n^4 * (V - E_K) - g_L * (V - E_L) + I_ext</a:t>
+            </a:r>
+          </a:p>
+          <a:p/>
+          <a:p>
+            <a:r>
+              <a:t>Where:</a:t>
+            </a:r>
+          </a:p>
+          <a:p>
+            <a:r>
+              <a:t>- C_m = membrane capacitance (~1 uF/cm2)</a:t>
+            </a:r>
+          </a:p>
+          <a:p>
+            <a:r>
+              <a:t>- g_Na, g_K, g_L = maximum conductances for sodium, potassium, and leak channels</a:t>
+            </a:r>
+          </a:p>
+          <a:p>
+            <a:r>
+              <a:t>- m, h, n = gating variables (0 to 1) that describe channel opening/closing probability</a:t>
+            </a:r>
+          </a:p>
+          <a:p>
+            <a:r>
+              <a:t>- E_Na, E_K, E_L = reversal (Nernst) potentials for each ion</a:t>
+            </a:r>
+          </a:p>
+          <a:p>
+            <a:r>
+              <a:t>- I_ext = external stimulation current</a:t>
+            </a:r>
+          </a:p>
+          <a:p/>
+          <a:p>
+            <a:r>
+              <a:t>The gating variables m, h, n each follow first-order kinetics: dx/dt = alpha_x(V)*(1-x) - beta_x(V)*x, where alpha and beta are voltage-dependent rate constants. Drug effects can be modeled by modifying these parameters: a Na+ channel blocker reduces g_Na, a K+ channel blocker reduces g_K.</a:t>
+            </a:r>
+          </a:p>
+          <a:p/>
+          <a:p>
+            <a:r>
+              <a:t>In the Week 1 practical notebook, students will simulate the Hodgkin-Huxley model and see how modifying conductances (simulating drug effects) changes firing patterns. This directly connects to the SpikerBot observations.</a:t>
+            </a:r>
+          </a:p>
+          <a:p/>
+          <a:p>
+            <a:r>
+              <a:t>=== HUMAN PHYSIOLOGY EXPERIMENTS ===</a:t>
+            </a:r>
+          </a:p>
+          <a:p>
+            <a:r>
+              <a:t>Students can use the SpikerBot / Muscle SpikerShield to record their OWN signals:</a:t>
+            </a:r>
+          </a:p>
+          <a:p>
+            <a:r>
+              <a:t>- EMG (electromyography): Record muscle electrical activity from the forearm. Observe motor unit recruitment. Compare grip strength to EMG amplitude.</a:t>
+            </a:r>
+          </a:p>
+          <a:p>
+            <a:r>
+              <a:t>- ECG (electrocardiography): Record heart rhythm. Identify P, QRS, T waves. Measure heart rate variability.</a:t>
+            </a:r>
+          </a:p>
+          <a:p>
+            <a:r>
+              <a:t>- Grip force experiments: Measure how stimulation frequency affects force (the SpikerBot can stimulate and record).</a:t>
+            </a:r>
+          </a:p>
+          <a:p/>
+          <a:p>
+            <a:r>
+              <a:t>The computational pipeline is IDENTICAL to drug discovery:</a:t>
+            </a:r>
+          </a:p>
+          <a:p>
+            <a:r>
+              <a:t>  Biological signal -&gt; digitize -&gt; extract features -&gt; build ML model -&gt; predict</a:t>
+            </a:r>
+          </a:p>
+          <a:p>
+            <a:r>
+              <a:t>  Molecular structure -&gt; fingerprint -&gt; extract features -&gt; build ML model -&gt; predict</a:t>
+            </a:r>
+          </a:p>
+          <a:p/>
+          <a:p>
+            <a:r>
+              <a:t>This parallel is the key teaching point: the same ML methods work across domains.</a:t>
             </a:r>
           </a:p>
         </p:txBody>
@@ -6669,7 +6905,7 @@
               </a:defRPr>
             </a:pPr>
             <a:r>
-              <a:t>From Neurons to Molecules: The Computational SpikerBox</a:t>
+              <a:t>Biophysical Modelling &amp; The Programmable SpikerBot</a:t>
             </a:r>
           </a:p>
         </p:txBody>
@@ -6708,190 +6944,206 @@
               </a:defRPr>
             </a:pPr>
             <a:r>
-              <a:t>The SpikerBox (Backyard Brains) - records real neural action potentials</a:t>
-            </a:r>
-          </a:p>
-          <a:p>
-            <a:pPr>
-              <a:spcAft>
-                <a:spcPts val="800"/>
-              </a:spcAft>
-              <a:defRPr sz="2000">
-                <a:solidFill>
-                  <a:srgbClr val="323232"/>
-                </a:solidFill>
-                <a:latin typeface="Calibri"/>
-              </a:defRPr>
-            </a:pPr>
-            <a:r>
-              <a:t>Marzullo et al. (2012), Advances in Physiology Education 36:2-14</a:t>
-            </a:r>
-          </a:p>
-          <a:p>
-            <a:pPr>
-              <a:spcAft>
-                <a:spcPts val="800"/>
-              </a:spcAft>
-              <a:defRPr sz="2000">
-                <a:solidFill>
-                  <a:srgbClr val="323232"/>
-                </a:solidFill>
-                <a:latin typeface="Calibri"/>
-              </a:defRPr>
-            </a:pPr>
-          </a:p>
-          <a:p>
-            <a:pPr>
-              <a:spcAft>
-                <a:spcPts val="800"/>
-              </a:spcAft>
-              <a:defRPr sz="2000">
-                <a:solidFill>
-                  <a:srgbClr val="323232"/>
-                </a:solidFill>
-                <a:latin typeface="Calibri"/>
-              </a:defRPr>
-            </a:pPr>
-            <a:r>
-              <a:t>Why is this relevant to drug discovery?</a:t>
-            </a:r>
-          </a:p>
-          <a:p>
-            <a:pPr>
-              <a:spcAft>
-                <a:spcPts val="800"/>
-              </a:spcAft>
-              <a:defRPr sz="2000">
-                <a:solidFill>
-                  <a:srgbClr val="323232"/>
-                </a:solidFill>
-                <a:latin typeface="Calibri"/>
-              </a:defRPr>
-            </a:pPr>
-            <a:r>
-              <a:t>  Ion channels are major drug targets (~18% of approved drugs)</a:t>
-            </a:r>
-          </a:p>
-          <a:p>
-            <a:pPr>
-              <a:spcAft>
-                <a:spcPts val="800"/>
-              </a:spcAft>
-              <a:defRPr sz="2000">
-                <a:solidFill>
-                  <a:srgbClr val="323232"/>
-                </a:solidFill>
-                <a:latin typeface="Calibri"/>
-              </a:defRPr>
-            </a:pPr>
-            <a:r>
-              <a:t>  Neural signals are driven by the same ion channels drugs modulate</a:t>
-            </a:r>
-          </a:p>
-          <a:p>
-            <a:pPr>
-              <a:spcAft>
-                <a:spcPts val="800"/>
-              </a:spcAft>
-              <a:defRPr sz="2000">
-                <a:solidFill>
-                  <a:srgbClr val="323232"/>
-                </a:solidFill>
-                <a:latin typeface="Calibri"/>
-              </a:defRPr>
-            </a:pPr>
-            <a:r>
-              <a:t>  The recording paradigm: biological signal -&gt; digitize -&gt; features -&gt; model</a:t>
-            </a:r>
-          </a:p>
-          <a:p>
-            <a:pPr>
-              <a:spcAft>
-                <a:spcPts val="800"/>
-              </a:spcAft>
-              <a:defRPr sz="2000">
-                <a:solidFill>
-                  <a:srgbClr val="323232"/>
-                </a:solidFill>
-                <a:latin typeface="Calibri"/>
-              </a:defRPr>
-            </a:pPr>
-          </a:p>
-          <a:p>
-            <a:pPr>
-              <a:spcAft>
-                <a:spcPts val="800"/>
-              </a:spcAft>
-              <a:defRPr sz="2000">
-                <a:solidFill>
-                  <a:srgbClr val="323232"/>
-                </a:solidFill>
-                <a:latin typeface="Calibri"/>
-              </a:defRPr>
-            </a:pPr>
-            <a:r>
-              <a:t>Same computational pipeline in drug discovery:</a:t>
-            </a:r>
-          </a:p>
-          <a:p>
-            <a:pPr>
-              <a:spcAft>
-                <a:spcPts val="800"/>
-              </a:spcAft>
-              <a:defRPr sz="2000">
-                <a:solidFill>
-                  <a:srgbClr val="323232"/>
-                </a:solidFill>
-                <a:latin typeface="Calibri"/>
-              </a:defRPr>
-            </a:pPr>
-            <a:r>
-              <a:t>  Molecular structure -&gt; fingerprint -&gt; features -&gt; ML model -&gt; prediction</a:t>
-            </a:r>
-          </a:p>
-          <a:p>
-            <a:pPr>
-              <a:spcAft>
-                <a:spcPts val="800"/>
-              </a:spcAft>
-              <a:defRPr sz="2000">
-                <a:solidFill>
-                  <a:srgbClr val="323232"/>
-                </a:solidFill>
-                <a:latin typeface="Calibri"/>
-              </a:defRPr>
-            </a:pPr>
-          </a:p>
-          <a:p>
-            <a:pPr>
-              <a:spcAft>
-                <a:spcPts val="800"/>
-              </a:spcAft>
-              <a:defRPr sz="2000">
-                <a:solidFill>
-                  <a:srgbClr val="323232"/>
-                </a:solidFill>
-                <a:latin typeface="Calibri"/>
-              </a:defRPr>
-            </a:pPr>
-            <a:r>
-              <a:t>The instructor's research: 512-channel ECoG brain-computer interfaces</a:t>
-            </a:r>
-          </a:p>
-          <a:p>
-            <a:pPr>
-              <a:spcAft>
-                <a:spcPts val="800"/>
-              </a:spcAft>
-              <a:defRPr sz="2000">
-                <a:solidFill>
-                  <a:srgbClr val="323232"/>
-                </a:solidFill>
-                <a:latin typeface="Calibri"/>
-              </a:defRPr>
-            </a:pPr>
-            <a:r>
-              <a:t>  (FUTRUE Neurosciences - same ML pipeline, different data domain!)</a:t>
+              <a:t>The SpikerBot (Backyard Brains) - record AND stimulate real neurons</a:t>
+            </a:r>
+          </a:p>
+          <a:p>
+            <a:pPr>
+              <a:spcAft>
+                <a:spcPts val="800"/>
+              </a:spcAft>
+              <a:defRPr sz="2000">
+                <a:solidFill>
+                  <a:srgbClr val="323232"/>
+                </a:solidFill>
+                <a:latin typeface="Calibri"/>
+              </a:defRPr>
+            </a:pPr>
+            <a:r>
+              <a:t>  Marzullo et al. (2012), Advances in Physiology Education 36:2-14</a:t>
+            </a:r>
+          </a:p>
+          <a:p>
+            <a:pPr>
+              <a:spcAft>
+                <a:spcPts val="800"/>
+              </a:spcAft>
+              <a:defRPr sz="2000">
+                <a:solidFill>
+                  <a:srgbClr val="323232"/>
+                </a:solidFill>
+                <a:latin typeface="Calibri"/>
+              </a:defRPr>
+            </a:pPr>
+          </a:p>
+          <a:p>
+            <a:pPr>
+              <a:spcAft>
+                <a:spcPts val="800"/>
+              </a:spcAft>
+              <a:defRPr sz="2000">
+                <a:solidFill>
+                  <a:srgbClr val="323232"/>
+                </a:solidFill>
+                <a:latin typeface="Calibri"/>
+              </a:defRPr>
+            </a:pPr>
+            <a:r>
+              <a:t>Programmable neural motifs you will explore:</a:t>
+            </a:r>
+          </a:p>
+          <a:p>
+            <a:pPr>
+              <a:spcAft>
+                <a:spcPts val="800"/>
+              </a:spcAft>
+              <a:defRPr sz="2000">
+                <a:solidFill>
+                  <a:srgbClr val="323232"/>
+                </a:solidFill>
+                <a:latin typeface="Calibri"/>
+              </a:defRPr>
+            </a:pPr>
+            <a:r>
+              <a:t>  Tonic firing - regular spikes (motor neurons, pacemaker cells)</a:t>
+            </a:r>
+          </a:p>
+          <a:p>
+            <a:pPr>
+              <a:spcAft>
+                <a:spcPts val="800"/>
+              </a:spcAft>
+              <a:defRPr sz="2000">
+                <a:solidFill>
+                  <a:srgbClr val="323232"/>
+                </a:solidFill>
+                <a:latin typeface="Calibri"/>
+              </a:defRPr>
+            </a:pPr>
+            <a:r>
+              <a:t>  Burst firing - clustered spikes (thalamic relay, dopamine neurons)</a:t>
+            </a:r>
+          </a:p>
+          <a:p>
+            <a:pPr>
+              <a:spcAft>
+                <a:spcPts val="800"/>
+              </a:spcAft>
+              <a:defRPr sz="2000">
+                <a:solidFill>
+                  <a:srgbClr val="323232"/>
+                </a:solidFill>
+                <a:latin typeface="Calibri"/>
+              </a:defRPr>
+            </a:pPr>
+            <a:r>
+              <a:t>  Irregular / Poisson firing - random intervals (cortical neurons)</a:t>
+            </a:r>
+          </a:p>
+          <a:p>
+            <a:pPr>
+              <a:spcAft>
+                <a:spcPts val="800"/>
+              </a:spcAft>
+              <a:defRPr sz="2000">
+                <a:solidFill>
+                  <a:srgbClr val="323232"/>
+                </a:solidFill>
+                <a:latin typeface="Calibri"/>
+              </a:defRPr>
+            </a:pPr>
+          </a:p>
+          <a:p>
+            <a:pPr>
+              <a:spcAft>
+                <a:spcPts val="800"/>
+              </a:spcAft>
+              <a:defRPr sz="2000">
+                <a:solidFill>
+                  <a:srgbClr val="323232"/>
+                </a:solidFill>
+                <a:latin typeface="Calibri"/>
+              </a:defRPr>
+            </a:pPr>
+            <a:r>
+              <a:t>Neuropharmacology connection:</a:t>
+            </a:r>
+          </a:p>
+          <a:p>
+            <a:pPr>
+              <a:spcAft>
+                <a:spcPts val="800"/>
+              </a:spcAft>
+              <a:defRPr sz="2000">
+                <a:solidFill>
+                  <a:srgbClr val="323232"/>
+                </a:solidFill>
+                <a:latin typeface="Calibri"/>
+              </a:defRPr>
+            </a:pPr>
+            <a:r>
+              <a:t>  Ion channels (Na+, K+, Ca2+) are major drug targets (~18% of approved drugs)</a:t>
+            </a:r>
+          </a:p>
+          <a:p>
+            <a:pPr>
+              <a:spcAft>
+                <a:spcPts val="800"/>
+              </a:spcAft>
+              <a:defRPr sz="2000">
+                <a:solidFill>
+                  <a:srgbClr val="323232"/>
+                </a:solidFill>
+                <a:latin typeface="Calibri"/>
+              </a:defRPr>
+            </a:pPr>
+            <a:r>
+              <a:t>  The Hodgkin-Huxley model (1952) describes how drugs alter channel gating</a:t>
+            </a:r>
+          </a:p>
+          <a:p>
+            <a:pPr>
+              <a:spcAft>
+                <a:spcPts val="800"/>
+              </a:spcAft>
+              <a:defRPr sz="2000">
+                <a:solidFill>
+                  <a:srgbClr val="323232"/>
+                </a:solidFill>
+                <a:latin typeface="Calibri"/>
+              </a:defRPr>
+            </a:pPr>
+            <a:r>
+              <a:t>  hERG (K+ channel) block -&gt; cardiac arrhythmia, #1 reason drugs are withdrawn</a:t>
+            </a:r>
+          </a:p>
+          <a:p>
+            <a:pPr>
+              <a:spcAft>
+                <a:spcPts val="800"/>
+              </a:spcAft>
+              <a:defRPr sz="2000">
+                <a:solidFill>
+                  <a:srgbClr val="323232"/>
+                </a:solidFill>
+                <a:latin typeface="Calibri"/>
+              </a:defRPr>
+            </a:pPr>
+          </a:p>
+          <a:p>
+            <a:pPr>
+              <a:spcAft>
+                <a:spcPts val="800"/>
+              </a:spcAft>
+              <a:defRPr sz="2000">
+                <a:solidFill>
+                  <a:srgbClr val="323232"/>
+                </a:solidFill>
+                <a:latin typeface="Calibri"/>
+              </a:defRPr>
+            </a:pPr>
+            <a:r>
+              <a:t>Same pipeline: biological signal -&gt; digitize -&gt; features -&gt; ML model</a:t>
             </a:r>
           </a:p>
         </p:txBody>

</xml_diff>

<commit_message>
Integrate neuroscience focus into all 4 weeks of slides: add Drosophila research, connectomics, GluCl/ivermectin, neurotransmitter SMILES, CNS drug examples, and detailed presenter notes referencing Serbe-Kamp's publications
Agent-Logs-Url: https://github.com/ETigerschuss/AI-Drug-Discovery/sessions/b58a42ca-23d0-4f6d-a552-be51e6356867

Co-authored-by: ETigerschuss <3415055+ETigerschuss@users.noreply.github.com>
</commit_message>
<xml_diff>
--- a/week1_introduction/slides.pptx
+++ b/week1_introduction/slides.pptx
@@ -521,7 +521,56 @@
           <a:lstStyle/>
           <a:p>
             <a:r>
-              <a:t>Welcome everyone to AI for Drug Discovery! Take a moment to introduce yourself and your background. Explain that this is a 7-week course plus a project week. The goal is to give students hands-on skills in applying ML/AI to pharmaceutical research. Today we cover the big picture: what drug discovery looks like, why it is so hard, and where AI changes the game. Spend about 2 minutes on introductions. Ask students: how many of you have a chemistry background? How many CS? This diversity is exactly what modern drug discovery teams look like.</a:t>
+              <a:t>Welcome everyone to AI for Drug Discovery! Take a moment to introduce yourself and your background.</a:t>
+            </a:r>
+          </a:p>
+          <a:p/>
+          <a:p>
+            <a:r>
+              <a:t>=== ABOUT YOUR INSTRUCTOR ===</a:t>
+            </a:r>
+          </a:p>
+          <a:p>
+            <a:r>
+              <a:t>Dr. Étienne Serbe-Kamp is a neuroscientist with a research background in computational and systems neuroscience, specifically in Drosophila (fruit fly) visual motion detection circuits. His key publications include:</a:t>
+            </a:r>
+          </a:p>
+          <a:p>
+            <a:r>
+              <a:t>- 'Multilevel visual motion opponency in Drosophila' (Nature Neuroscience, 2023) - discovered how GluClα-mediated inhibition creates direction-selective motion opponency across three network levels</a:t>
+            </a:r>
+          </a:p>
+          <a:p>
+            <a:r>
+              <a:t>- 'Voltage to Calcium Transformation Enhances Direction Selectivity in Drosophila T4 Neurons' (J. Neurosci., 2023)</a:t>
+            </a:r>
+          </a:p>
+          <a:p>
+            <a:r>
+              <a:t>- 'Comprehensive Characterization of the Major Presynaptic Elements to the Drosophila OFF Motion Detector' (Neuron, 2016)</a:t>
+            </a:r>
+          </a:p>
+          <a:p>
+            <a:r>
+              <a:t>- 'A Directional Tuning Map of Drosophila Elementary Motion Detectors' (Nature, 2013)</a:t>
+            </a:r>
+          </a:p>
+          <a:p/>
+          <a:p>
+            <a:r>
+              <a:t>He is also Co-Director of Summer Fellowships at Backyard Brains, where he develops open-source neuroscience tools (SpikerBox/SpikerBot) and leads citizen science projects including 'A Library of Electrophysiological Responses in Plants' (2024) and the ERGo! platform for electroretinogram recording.</a:t>
+            </a:r>
+          </a:p>
+          <a:p/>
+          <a:p>
+            <a:r>
+              <a:t>Why is a neuroscientist teaching drug discovery? Because the tools are the same! The computational pipeline (signal -&gt; features -&gt; model -&gt; prediction) is identical whether you are studying neural circuits, molecular properties, or physiological signals. And many of the most important drug targets in the world are proteins that Dr. Serbe-Kamp studies directly: ion channels, neurotransmitter receptors, and synaptic signaling molecules.</a:t>
+            </a:r>
+          </a:p>
+          <a:p/>
+          <a:p>
+            <a:r>
+              <a:t>Tell the class: this course will blend neuroscience, pharmacology, and AI/ML. We will use real neuroscience examples alongside drug discovery, because understanding the biology of drug targets makes you a better computational scientist.</a:t>
             </a:r>
           </a:p>
         </p:txBody>
@@ -591,7 +640,59 @@
           <a:lstStyle/>
           <a:p>
             <a:r>
-              <a:t>AlphaFold is probably the most famous AI success story in biology. Spend 3 minutes here. Jumper J. et al. (2021) Highly accurate protein structure prediction with AlphaFold, Nature 596:583-589, won the 2024 Nobel Prize in Chemistry for Demis Hassabis and John Jumper. AlphaFold3 (Abramson et al. 2024, Nature) extends to protein-ligand complexes, directly relevant to drug design. We will revisit protein structures in Week 6.</a:t>
+              <a:t>AlphaFold is probably the most famous AI success story in biology. Spend 3 minutes here.</a:t>
+            </a:r>
+          </a:p>
+          <a:p/>
+          <a:p>
+            <a:r>
+              <a:t>=== KEY DETAILS ===</a:t>
+            </a:r>
+          </a:p>
+          <a:p>
+            <a:r>
+              <a:t>Jumper J. et al. (2021) Highly accurate protein structure prediction with AlphaFold, Nature 596:583-589. Won the 2024 Nobel Prize in Chemistry for Demis Hassabis and John Jumper. AlphaFold3 (Abramson et al. 2024, Nature) extends to protein-ligand complexes.</a:t>
+            </a:r>
+          </a:p>
+          <a:p/>
+          <a:p>
+            <a:r>
+              <a:t>=== NEUROSCIENCE CONNECTION ===</a:t>
+            </a:r>
+          </a:p>
+          <a:p>
+            <a:r>
+              <a:t>The most important drug target families in neuroscience ALL benefit from AlphaFold:</a:t>
+            </a:r>
+          </a:p>
+          <a:p/>
+          <a:p>
+            <a:r>
+              <a:t>1. ION CHANNELS: AlphaFold has predicted structures for many ion channel families. For example, the GluCl (glutamate-gated chloride channel) that Dr. Serbe-Kamp's research involves is part of the Cys-loop receptor superfamily. The crystal structure of C. elegans GluCl bound to ivermectin was solved by Hibbs &amp; Bhatt (2007, Nature 474:54-60) and AlphaFold predicts related structures. Understanding these structures helps design better drugs.</a:t>
+            </a:r>
+          </a:p>
+          <a:p/>
+          <a:p>
+            <a:r>
+              <a:t>2. GPCRs (G-Protein Coupled Receptors): ~34% of all FDA-approved drugs target GPCRs. These include serotonin receptors (5-HT, targeted by antidepressants like fluoxetine/Prozac), dopamine receptors (targeted by antipsychotics like haloperidol), and opioid receptors (targeted by morphine, fentanyl). AlphaFold2 predicted structures of many GPCRs.</a:t>
+            </a:r>
+          </a:p>
+          <a:p/>
+          <a:p>
+            <a:r>
+              <a:t>3. NEUROTRANSMITTER TRANSPORTERS: The serotonin transporter (SERT, target of SSRIs), dopamine transporter (DAT, target of methylphenidate/Ritalin), and GABA transporters all have AlphaFold-predicted structures.</a:t>
+            </a:r>
+          </a:p>
+          <a:p/>
+          <a:p>
+            <a:r>
+              <a:t>4. GABA-A RECEPTORS: Targeted by benzodiazepines (Valium, Xanax), barbiturates, and general anesthetics. These are pentameric ligand-gated ion channels, same superfamily as GluCl.</a:t>
+            </a:r>
+          </a:p>
+          <a:p/>
+          <a:p>
+            <a:r>
+              <a:t>Key point: AlphaFold enables structure-based drug design for targets that were previously too hard to crystallize, many of which are membrane proteins critical to neuroscience.</a:t>
             </a:r>
           </a:p>
         </p:txBody>
@@ -731,7 +832,124 @@
           <a:lstStyle/>
           <a:p>
             <a:r>
-              <a:t>Spend 3-4 minutes on SMILES. Key rules: atoms are letters, single bonds are implicit, double bonds =, triple bonds #, branches in parentheses, rings with number pairs. Lowercase letters mean aromatic atoms. The Weininger 1988 paper is the original reference. We will go much deeper into SMILES in Week 2. For now, just get comfortable with the idea that molecules can be written as strings for machine learning models. Ask: can anyone guess what c1ccccc1 represents? It is benzene!</a:t>
+              <a:t>Spend 3-4 minutes on SMILES. Key rules: atoms are letters, single bonds are implicit, double bonds =, triple bonds #, branches in parentheses, rings with number pairs. Lowercase letters mean aromatic atoms. The Weininger 1988 paper is the original reference.</a:t>
+            </a:r>
+          </a:p>
+          <a:p/>
+          <a:p>
+            <a:r>
+              <a:t>=== NEUROSCIENCE DRUG SMILES ===</a:t>
+            </a:r>
+          </a:p>
+          <a:p>
+            <a:r>
+              <a:t>We specifically include neurotransmitters and CNS drugs here because they are central to drug discovery:</a:t>
+            </a:r>
+          </a:p>
+          <a:p/>
+          <a:p>
+            <a:r>
+              <a:t>1. SEROTONIN (5-hydroxytryptamine, 5-HT): NCCc1c[nH]c2ccc(O)cc12</a:t>
+            </a:r>
+          </a:p>
+          <a:p>
+            <a:r>
+              <a:t>   - An indolamine neurotransmitter. Contains an indole ring (tryptophan derivative) and an ethylamine side chain.</a:t>
+            </a:r>
+          </a:p>
+          <a:p>
+            <a:r>
+              <a:t>   - 14 serotonin receptor subtypes (5-HT1A through 5-HT7), all GPCRs except 5-HT3 (ion channel).</a:t>
+            </a:r>
+          </a:p>
+          <a:p>
+            <a:r>
+              <a:t>   - Drug targets: SSRIs (fluoxetine/Prozac blocks serotonin reuptake), triptans (sumatriptan for migraine), LSD (5-HT2A agonist).</a:t>
+            </a:r>
+          </a:p>
+          <a:p>
+            <a:r>
+              <a:t>   - Ask students: can you identify the hydroxyl group (O) and the amine (N) in the SMILES?</a:t>
+            </a:r>
+          </a:p>
+          <a:p/>
+          <a:p>
+            <a:r>
+              <a:t>2. DOPAMINE: NCCc1ccc(O)c(O)c1</a:t>
+            </a:r>
+          </a:p>
+          <a:p>
+            <a:r>
+              <a:t>   - A catecholamine neurotransmitter. Contains a catechol ring (two adjacent OH groups) and an ethylamine.</a:t>
+            </a:r>
+          </a:p>
+          <a:p>
+            <a:r>
+              <a:t>   - 5 dopamine receptor subtypes (D1-D5).</a:t>
+            </a:r>
+          </a:p>
+          <a:p>
+            <a:r>
+              <a:t>   - Drug targets: L-DOPA for Parkinson's, antipsychotics (haloperidol blocks D2), methylphenidate (Ritalin, blocks DAT).</a:t>
+            </a:r>
+          </a:p>
+          <a:p/>
+          <a:p>
+            <a:r>
+              <a:t>3. GABA (gamma-aminobutyric acid): NCCCC(=O)O</a:t>
+            </a:r>
+          </a:p>
+          <a:p>
+            <a:r>
+              <a:t>   - The main inhibitory neurotransmitter in the brain. Very simple structure: 4-carbon chain with amine and carboxyl groups.</a:t>
+            </a:r>
+          </a:p>
+          <a:p>
+            <a:r>
+              <a:t>   - GABA-A receptors are ligand-gated Cl- channels (same superfamily as GluCl that Dr. Serbe-Kamp studies!).</a:t>
+            </a:r>
+          </a:p>
+          <a:p>
+            <a:r>
+              <a:t>   - Drug targets: benzodiazepines (diazepam/Valium, alprazolam/Xanax), barbiturates, general anesthetics (propofol), alcohol.</a:t>
+            </a:r>
+          </a:p>
+          <a:p/>
+          <a:p>
+            <a:r>
+              <a:t>4. DIAZEPAM (Valium): ClC1=CC2=C(C=C1)N(C)C(=O)CN2</a:t>
+            </a:r>
+          </a:p>
+          <a:p>
+            <a:r>
+              <a:t>   - A benzodiazepine that enhances GABA-A receptor function (positive allosteric modulator).</a:t>
+            </a:r>
+          </a:p>
+          <a:p>
+            <a:r>
+              <a:t>   - Notice the chlorine (Cl), the fused ring system, and the nitrogen atoms in the SMILES.</a:t>
+            </a:r>
+          </a:p>
+          <a:p/>
+          <a:p>
+            <a:r>
+              <a:t>5. CAFFEINE: Cn1c(=O)c2c(ncn2C)n(C)c1=O</a:t>
+            </a:r>
+          </a:p>
+          <a:p>
+            <a:r>
+              <a:t>   - Adenosine receptor antagonist (blocks A1 and A2A receptors).</a:t>
+            </a:r>
+          </a:p>
+          <a:p>
+            <a:r>
+              <a:t>   - A xanthine derivative. Students will experiment with caffeine using the SpikerBot!</a:t>
+            </a:r>
+          </a:p>
+          <a:p/>
+          <a:p>
+            <a:r>
+              <a:t>The point: SMILES can represent ALL of these neuroscience-relevant molecules as simple text strings, ready for ML.</a:t>
             </a:r>
           </a:p>
         </p:txBody>
@@ -801,7 +1019,154 @@
           <a:lstStyle/>
           <a:p>
             <a:r>
-              <a:t>Spend 3 minutes explaining bioactivity measures. Use an analogy: IC50 is like asking how much of this molecule do I need to shut down 50% of the enzyme? Lower IC50 = more potent = better drug. We convert to pIC50 because it makes the numbers easier to work with. A pIC50 of 8 means IC50 = 10nM, that is a very potent drug candidate. ChEMBL maintained by the European Bioinformatics Institute is the gold standard. We will use ChEMBL data extensively in our practicals.</a:t>
+              <a:t>Spend 3-4 minutes explaining bioactivity measures.</a:t>
+            </a:r>
+          </a:p>
+          <a:p/>
+          <a:p>
+            <a:r>
+              <a:t>=== CORE CONCEPTS ===</a:t>
+            </a:r>
+          </a:p>
+          <a:p>
+            <a:r>
+              <a:t>IC50 analogy: how much drug do I need to shut down 50% of the enzyme/channel/receptor? Lower IC50 = more potent. pIC50 = -log10(IC50 in M). A pIC50 of 8 means IC50 = 10nM, very potent.</a:t>
+            </a:r>
+          </a:p>
+          <a:p/>
+          <a:p>
+            <a:r>
+              <a:t>=== NEUROSCIENCE ASSAYS ===</a:t>
+            </a:r>
+          </a:p>
+          <a:p>
+            <a:r>
+              <a:t>The bioactivity data in ChEMBL comes from actual laboratory experiments. For neuroscience targets, the key assay types are:</a:t>
+            </a:r>
+          </a:p>
+          <a:p/>
+          <a:p>
+            <a:r>
+              <a:t>1. PATCH-CLAMP ELECTROPHYSIOLOGY:</a:t>
+            </a:r>
+          </a:p>
+          <a:p>
+            <a:r>
+              <a:t>   - The gold standard for measuring ion channel activity.</a:t>
+            </a:r>
+          </a:p>
+          <a:p>
+            <a:r>
+              <a:t>   - A glass micropipette (tip ~1 µm) seals onto a cell membrane, isolating a tiny patch of membrane or the whole cell.</a:t>
+            </a:r>
+          </a:p>
+          <a:p>
+            <a:r>
+              <a:t>   - You can measure the current flowing through individual ion channels.</a:t>
+            </a:r>
+          </a:p>
+          <a:p>
+            <a:r>
+              <a:t>   - For drug discovery: apply increasing concentrations of a drug while recording channel current. The concentration that reduces current by 50% is the IC50.</a:t>
+            </a:r>
+          </a:p>
+          <a:p>
+            <a:r>
+              <a:t>   - This is EXACTLY what Dr. Serbe-Kamp does in his Drosophila research: recording from neurons while manipulating pharmacology or optogenetics.</a:t>
+            </a:r>
+          </a:p>
+          <a:p>
+            <a:r>
+              <a:t>   - For hERG safety testing: patch-clamp HEK293 cells expressing hERG channels, measure block IC50.</a:t>
+            </a:r>
+          </a:p>
+          <a:p>
+            <a:r>
+              <a:t>   - Automated patch-clamp machines (SyncroPatch, QPatch) can test thousands of compounds per day.</a:t>
+            </a:r>
+          </a:p>
+          <a:p/>
+          <a:p>
+            <a:r>
+              <a:t>2. CALCIUM IMAGING (two-photon, confocal):</a:t>
+            </a:r>
+          </a:p>
+          <a:p>
+            <a:r>
+              <a:t>   - Load neurons with calcium-sensitive fluorescent dyes (GCaMP, Oregon Green BAPTA).</a:t>
+            </a:r>
+          </a:p>
+          <a:p>
+            <a:r>
+              <a:t>   - When a neuron fires, Ca2+ floods in, increasing fluorescence.</a:t>
+            </a:r>
+          </a:p>
+          <a:p>
+            <a:r>
+              <a:t>   - For drug screening: measure changes in calcium transient amplitude/frequency after drug application.</a:t>
+            </a:r>
+          </a:p>
+          <a:p>
+            <a:r>
+              <a:t>   - Dr. Serbe-Kamp's 2023 J. Neurosci. paper used two-photon calcium imaging in Drosophila T4 neurons to show how voltage-to-calcium transformation enhances direction selectivity.</a:t>
+            </a:r>
+          </a:p>
+          <a:p>
+            <a:r>
+              <a:t>   - For drug discovery: high-throughput calcium imaging (FLIPR assay) screens GPCR agonists/antagonists.</a:t>
+            </a:r>
+          </a:p>
+          <a:p/>
+          <a:p>
+            <a:r>
+              <a:t>3. RADIOLIGAND BINDING:</a:t>
+            </a:r>
+          </a:p>
+          <a:p>
+            <a:r>
+              <a:t>   - Classic method to measure drug-receptor affinity.</a:t>
+            </a:r>
+          </a:p>
+          <a:p>
+            <a:r>
+              <a:t>   - Incubate membrane preparations with a radioactive ligand, then add test compounds.</a:t>
+            </a:r>
+          </a:p>
+          <a:p>
+            <a:r>
+              <a:t>   - The Ki (inhibition constant) reflects binding affinity.</a:t>
+            </a:r>
+          </a:p>
+          <a:p>
+            <a:r>
+              <a:t>   - Example: measuring Ki of antipsychotics at dopamine D2 receptors. Haloperidol has Ki ~1 nM.</a:t>
+            </a:r>
+          </a:p>
+          <a:p/>
+          <a:p>
+            <a:r>
+              <a:t>4. FUNCTIONAL ASSAYS:</a:t>
+            </a:r>
+          </a:p>
+          <a:p>
+            <a:r>
+              <a:t>   - cAMP assays for GPCR signaling</a:t>
+            </a:r>
+          </a:p>
+          <a:p>
+            <a:r>
+              <a:t>   - FLIPR for calcium-mobilizing receptors</a:t>
+            </a:r>
+          </a:p>
+          <a:p>
+            <a:r>
+              <a:t>   - GTPγS binding for G-protein activation</a:t>
+            </a:r>
+          </a:p>
+          <a:p/>
+          <a:p>
+            <a:r>
+              <a:t>Key point: the pIC50 values that our ML models predict ultimately come from these laboratory measurements. Understanding the assay helps you understand the data quality and biological meaning.</a:t>
             </a:r>
           </a:p>
         </p:txBody>
@@ -941,243 +1306,298 @@
           <a:lstStyle/>
           <a:p>
             <a:r>
-              <a:t>DETAILED PRESENTER NOTES - BIOPHYSICAL MODELLING &amp; SPIKERBOT</a:t>
+              <a:t>DETAILED PRESENTER NOTES - BIOPHYSICAL MODELLING, SPIKERBOT &amp; DROSOPHILA NEUROSCIENCE</a:t>
             </a:r>
           </a:p>
           <a:p/>
           <a:p>
             <a:r>
-              <a:t>Spend 5-7 minutes on this slide. This is a unique hands-on connection between neuroscience and drug discovery.</a:t>
+              <a:t>Spend 5-7 minutes on this slide. This bridges neuroscience, the instructor's research, and drug discovery.</a:t>
             </a:r>
           </a:p>
           <a:p/>
           <a:p>
             <a:r>
-              <a:t>=== THE SPIKERBOT ===</a:t>
-            </a:r>
-          </a:p>
-          <a:p>
-            <a:r>
-              <a:t>The SpikerBot is made by Backyard Brains (backyardbrains.com). It is an open-source neuroscience education platform that can both RECORD and STIMULATE neural signals. The original SpikerBox paper is Marzullo &amp; Gage (2012), Advances in Physiology Education 36:2-14. The SpikerBot extends this with programmable stimulation and a robotic gripper controlled by neural signals.</a:t>
+              <a:t>=== DR. SERBE-KAMP'S RESEARCH &amp; THE SPIKERBOT ===</a:t>
+            </a:r>
+          </a:p>
+          <a:p>
+            <a:r>
+              <a:t>Dr. Serbe-Kamp is Co-Director of Summer Fellowships at Backyard Brains (backyardbrains.com), the company that makes the SpikerBox and SpikerBot. He has led international citizen science projects including:</a:t>
+            </a:r>
+          </a:p>
+          <a:p>
+            <a:r>
+              <a:t>- 'A Library of Electrophysiological Responses in Plants' (Plant Signaling &amp; Behavior, 2024) - students from multiple countries recorded plant electrical signals using SpikerBoxes</a:t>
+            </a:r>
+          </a:p>
+          <a:p>
+            <a:r>
+              <a:t>- The ERGo! platform for electroretinogram recording from insect eyes - citizen science biodiversity monitoring</a:t>
+            </a:r>
+          </a:p>
+          <a:p>
+            <a:r>
+              <a:t>- 'Authentic Research Investigations: Can Plants Learn?' - engaging students in real research</a:t>
             </a:r>
           </a:p>
           <a:p/>
           <a:p>
             <a:r>
-              <a:t>Key hardware components:</a:t>
-            </a:r>
-          </a:p>
-          <a:p>
-            <a:r>
-              <a:t>- Electrodes that interface with biological tissue (cockroach leg, earthworm, or human EMG)</a:t>
-            </a:r>
-          </a:p>
-          <a:p>
-            <a:r>
-              <a:t>- Amplifier that boosts microvolt signals to measurable range</a:t>
-            </a:r>
-          </a:p>
-          <a:p>
-            <a:r>
-              <a:t>- ADC (analog-to-digital converter) that digitizes the signal</a:t>
-            </a:r>
-          </a:p>
-          <a:p>
-            <a:r>
-              <a:t>- Microcontroller (Arduino-compatible) for programmable stimulation</a:t>
-            </a:r>
-          </a:p>
-          <a:p>
-            <a:r>
-              <a:t>- Software: Spike Recorder app for visualization and analysis</a:t>
+              <a:t>The SpikerBot extends the SpikerBox with programmable stimulation and a robotic gripper. Key hardware:</a:t>
+            </a:r>
+          </a:p>
+          <a:p>
+            <a:r>
+              <a:t>- Electrodes for biological tissue (cockroach leg, earthworm, human EMG)</a:t>
+            </a:r>
+          </a:p>
+          <a:p>
+            <a:r>
+              <a:t>- Amplifier (microvolt signals to measurable range)</a:t>
+            </a:r>
+          </a:p>
+          <a:p>
+            <a:r>
+              <a:t>- ADC (analog-to-digital converter)</a:t>
+            </a:r>
+          </a:p>
+          <a:p>
+            <a:r>
+              <a:t>- Arduino-compatible microcontroller for programmable stimulation</a:t>
+            </a:r>
+          </a:p>
+          <a:p>
+            <a:r>
+              <a:t>- Spike Recorder app for visualization</a:t>
             </a:r>
           </a:p>
           <a:p/>
           <a:p>
             <a:r>
+              <a:t>=== DROSOPHILA VISUAL NEUROSCIENCE -&gt; DRUG TARGETS ===</a:t>
+            </a:r>
+          </a:p>
+          <a:p>
+            <a:r>
+              <a:t>Dr. Serbe-Kamp's core research is on how the Drosophila (fruit fly) brain computes visual motion. Key publications:</a:t>
+            </a:r>
+          </a:p>
+          <a:p/>
+          <a:p>
+            <a:r>
+              <a:t>1. 'A Directional Tuning Map of Drosophila Elementary Motion Detectors' (Maisak, Haag, Ammer, Serbe et al., 2013, Nature 500:212-216)</a:t>
+            </a:r>
+          </a:p>
+          <a:p>
+            <a:r>
+              <a:t>   - Mapped how T4 (ON) and T5 (OFF) neurons in the fly optic lobe respond to different directions of motion.</a:t>
+            </a:r>
+          </a:p>
+          <a:p>
+            <a:r>
+              <a:t>   - These neurons are organized in 4 layers, each tuned to one of four cardinal directions.</a:t>
+            </a:r>
+          </a:p>
+          <a:p>
+            <a:r>
+              <a:t>   - This was the first comprehensive directional tuning map of the fly motion detection circuit.</a:t>
+            </a:r>
+          </a:p>
+          <a:p/>
+          <a:p>
+            <a:r>
+              <a:t>2. 'Comprehensive Characterization of the Major Presynaptic Elements to the Drosophila OFF Motion Detector' (Serbe et al., 2016, Neuron 89:829-841)</a:t>
+            </a:r>
+          </a:p>
+          <a:p>
+            <a:r>
+              <a:t>   - Used EM connectomics, calcium imaging, electrophysiology, and optogenetics to map ALL inputs to T5 neurons.</a:t>
+            </a:r>
+          </a:p>
+          <a:p>
+            <a:r>
+              <a:t>   - Identified specific medulla interneuron types (Tm1, Tm2, Tm4, Tm9) providing input.</a:t>
+            </a:r>
+          </a:p>
+          <a:p>
+            <a:r>
+              <a:t>   - This is connectomics in action: mapping the complete wiring diagram of a neural circuit.</a:t>
+            </a:r>
+          </a:p>
+          <a:p/>
+          <a:p>
+            <a:r>
+              <a:t>3. 'Multilevel visual motion opponency in Drosophila' (Haag, Arenz, Serbe-Kamp et al., 2023, Nature Neuroscience 26:1894-1903)</a:t>
+            </a:r>
+          </a:p>
+          <a:p>
+            <a:r>
+              <a:t>   - Discovered that GluClα (glutamate-gated chloride channel) mediates direction-opponent inhibition.</a:t>
+            </a:r>
+          </a:p>
+          <a:p>
+            <a:r>
+              <a:t>   - A single neuron type implements inhibition at THREE different levels of the circuit.</a:t>
+            </a:r>
+          </a:p>
+          <a:p>
+            <a:r>
+              <a:t>   - GluClα is the SAME receptor family targeted by IVERMECTIN!</a:t>
+            </a:r>
+          </a:p>
+          <a:p/>
+          <a:p>
+            <a:r>
+              <a:t>4. 'Voltage to Calcium Transformation Enhances Direction Selectivity in Drosophila T4 Neurons' (Serbe-Kamp et al., 2023, J. Neurosci. 43:2497-2514)</a:t>
+            </a:r>
+          </a:p>
+          <a:p>
+            <a:r>
+              <a:t>   - Used two-photon calcium imaging + computational modeling.</a:t>
+            </a:r>
+          </a:p>
+          <a:p>
+            <a:r>
+              <a:t>   - Showed that the nonlinear voltage-to-calcium transformation in T4 neuron dendrites enhances direction selectivity.</a:t>
+            </a:r>
+          </a:p>
+          <a:p/>
+          <a:p>
+            <a:r>
+              <a:t>=== THE GluCl / IVERMECTIN CONNECTION ===</a:t>
+            </a:r>
+          </a:p>
+          <a:p>
+            <a:r>
+              <a:t>This is the DIRECT link between Dr. Serbe-Kamp's research and drug discovery:</a:t>
+            </a:r>
+          </a:p>
+          <a:p/>
+          <a:p>
+            <a:r>
+              <a:t>GluCl (glutamate-gated chloride channel) is a member of the Cys-loop ligand-gated ion channel superfamily (same family as GABA-A, glycine receptors, nAChR).</a:t>
+            </a:r>
+          </a:p>
+          <a:p/>
+          <a:p>
+            <a:r>
+              <a:t>Ivermectin was discovered by Satoshi Ōmura and William Campbell (2015 Nobel Prize in Physiology or Medicine). It is:</a:t>
+            </a:r>
+          </a:p>
+          <a:p>
+            <a:r>
+              <a:t>- An antiparasitic drug that targets GluCl channels in nematode and arthropod neurons</a:t>
+            </a:r>
+          </a:p>
+          <a:p>
+            <a:r>
+              <a:t>- One of the WHO Essential Medicines</a:t>
+            </a:r>
+          </a:p>
+          <a:p>
+            <a:r>
+              <a:t>- Treats river blindness (onchocerciasis), elephantiasis (lymphatic filariasis), scabies, head lice</a:t>
+            </a:r>
+          </a:p>
+          <a:p>
+            <a:r>
+              <a:t>- The mechanism: ivermectin binds to GluCl channels and locks them OPEN, causing an influx of Cl- ions that hyperpolarizes the neuron, paralyzing the parasite</a:t>
+            </a:r>
+          </a:p>
+          <a:p>
+            <a:r>
+              <a:t>- In Dr. Serbe-Kamp's research, GluClα mediates inhibition in the Drosophila motion detection circuit</a:t>
+            </a:r>
+          </a:p>
+          <a:p/>
+          <a:p>
+            <a:r>
+              <a:t>Insecticide connection: Avermectins (the class ivermectin belongs to) are used as both DRUGS and INSECTICIDES. Abamectin is a widely used agricultural insecticide that targets the same GluCl channels in pest insects. This is a beautiful example of how basic neuroscience research (understanding ion channel function in flies) directly translates to both drug discovery AND crop protection.</a:t>
+            </a:r>
+          </a:p>
+          <a:p/>
+          <a:p>
+            <a:r>
+              <a:t>=== NEUROPHARMACOLOGY ON THE SPIKERBOT ===</a:t>
+            </a:r>
+          </a:p>
+          <a:p>
+            <a:r>
+              <a:t>Ion channel drugs that can be demonstrated:</a:t>
+            </a:r>
+          </a:p>
+          <a:p>
+            <a:r>
+              <a:t>- Lidocaine (Nav blocker): apply to cockroach leg preparation, observe abolishment of action potentials</a:t>
+            </a:r>
+          </a:p>
+          <a:p>
+            <a:r>
+              <a:t>- Caffeine (adenosine antagonist): record your own EMG before and after coffee</a:t>
+            </a:r>
+          </a:p>
+          <a:p>
+            <a:r>
+              <a:t>- Nicotine (nAChR agonist): enhances neural excitability (DO NOT use in class, just discuss)</a:t>
+            </a:r>
+          </a:p>
+          <a:p/>
+          <a:p>
+            <a:r>
+              <a:t>=== THE HODGKIN-HUXLEY MODEL ===</a:t>
+            </a:r>
+          </a:p>
+          <a:p>
+            <a:r>
+              <a:t>Hodgkin &amp; Huxley (1952), J. Physiol. 117:500-544 (Nobel Prize 1963)</a:t>
+            </a:r>
+          </a:p>
+          <a:p>
+            <a:r>
+              <a:t>C_m * dV/dt = -g_Na * m^3 * h * (V - E_Na) - g_K * n^4 * (V - E_K) - g_L * (V - E_L) + I_ext</a:t>
+            </a:r>
+          </a:p>
+          <a:p>
+            <a:r>
+              <a:t>Drug effects = modifying conductance parameters. We simulate this in the Week 1 notebook.</a:t>
+            </a:r>
+          </a:p>
+          <a:p/>
+          <a:p>
+            <a:r>
               <a:t>=== PROGRAMMABLE NEURAL MOTIFS ===</a:t>
             </a:r>
           </a:p>
           <a:p>
             <a:r>
-              <a:t>The SpikerBot can be programmed to deliver different electrical stimulation patterns, and you can observe the neural response in real-time:</a:t>
+              <a:t>1. TONIC: Regular spikes. Like Drosophila lobula plate tangential cells (HS/VS cells) responding to sustained motion.</a:t>
+            </a:r>
+          </a:p>
+          <a:p>
+            <a:r>
+              <a:t>2. BURST: Clustered spikes. Like thalamic neurons in sleep, or dopamine neurons signaling reward.</a:t>
+            </a:r>
+          </a:p>
+          <a:p>
+            <a:r>
+              <a:t>3. IRREGULAR: Random intervals (Poisson). Like cortical neurons during wakefulness.</a:t>
+            </a:r>
+          </a:p>
+          <a:p>
+            <a:r>
+              <a:t>Students program the SpikerBot to generate each motif and observe the muscle response.</a:t>
             </a:r>
           </a:p>
           <a:p/>
           <a:p>
             <a:r>
-              <a:t>1. TONIC FIRING: Regular, evenly-spaced action potentials. This is what you see in motor neurons during sustained muscle contraction, or in cardiac pacemaker cells. On the SpikerBot, program this as a constant-frequency pulse train (e.g., 10 Hz = one pulse every 100 ms). Students should observe that increasing stimulation frequency increases muscle contraction force (temporal summation).</a:t>
-            </a:r>
-          </a:p>
-          <a:p/>
-          <a:p>
-            <a:r>
-              <a:t>2. BURST FIRING: Clusters of rapid spikes separated by silent periods. This is characteristic of thalamocortical relay neurons (involved in sleep spindles and absence seizures), dopaminergic neurons in the VTA (reward signaling), and hippocampal place cells. On the SpikerBot, program this as 3-5 rapid pulses at 50-100 Hz, then a 200-500 ms pause, then repeat. Burst firing is more effective at triggering synaptic plasticity than tonic firing at the same average rate.</a:t>
-            </a:r>
-          </a:p>
-          <a:p/>
-          <a:p>
-            <a:r>
-              <a:t>3. IRREGULAR / POISSON FIRING: Random inter-spike intervals following an exponential distribution. This is the dominant pattern in cortical neurons during wakefulness. On the SpikerBot, program this with randomized inter-pulse intervals drawn from an exponential distribution with a given mean rate. Students should compare the muscle response to irregular vs. regular stimulation at the same average rate.</a:t>
-            </a:r>
-          </a:p>
-          <a:p/>
-          <a:p>
-            <a:r>
-              <a:t>=== NEUROPHARMACOLOGY ===</a:t>
-            </a:r>
-          </a:p>
-          <a:p>
-            <a:r>
-              <a:t>This is where the SpikerBot connects directly to drug discovery:</a:t>
-            </a:r>
-          </a:p>
-          <a:p/>
-          <a:p>
-            <a:r>
-              <a:t>Ion channels are transmembrane proteins that allow ions (Na+, K+, Ca2+, Cl-) to flow across cell membranes. They are essential for ALL electrical signaling in the body: neurons, muscles, heart. About 18% of all FDA-approved drugs target ion channels (Santos et al. 2017, Nature Reviews Drug Discovery 16:19-34).</a:t>
-            </a:r>
-          </a:p>
-          <a:p/>
-          <a:p>
-            <a:r>
-              <a:t>Key ion channel drug targets:</a:t>
-            </a:r>
-          </a:p>
-          <a:p>
-            <a:r>
-              <a:t>- Voltage-gated Na+ channels (Nav): Targeted by local anesthetics (lidocaine, bupivacaine), anti-epileptics (carbamazepine, phenytoin, lamotrigine), and some analgesics. These drugs block the channel pore, preventing Na+ influx and thus preventing action potentials. With the SpikerBot, applying lidocaine to a cockroach leg preparation will reduce/abolish action potentials in real-time.</a:t>
-            </a:r>
-          </a:p>
-          <a:p/>
-          <a:p>
-            <a:r>
-              <a:t>- Voltage-gated K+ channels (Kv): The hERG channel (Kv11.1, encoded by KCNH2 gene) is the SINGLE MOST IMPORTANT safety target in all of drug development. Blocking hERG causes QT interval prolongation on the ECG, which can lead to a lethal cardiac arrhythmia called Torsades de Pointes. Multiple drugs have been withdrawn from the market for hERG liability: terfenadine (Seldane), cisapride (Propulsid), astemizole. Today, hERG screening is MANDATORY for all drug candidates (ICH S7B guideline). ML models for hERG prediction are a hot research area.</a:t>
-            </a:r>
-          </a:p>
-          <a:p/>
-          <a:p>
-            <a:r>
-              <a:t>- Voltage-gated Ca2+ channels (Cav): Targeted by anti-hypertensives (amlodipine, nifedipine - L-type blockers), anti-epileptics (ethosuximide - T-type blockers), and pain drugs (gabapentin targets alpha-2-delta subunit).</a:t>
-            </a:r>
-          </a:p>
-          <a:p/>
-          <a:p>
-            <a:r>
-              <a:t>- Ligand-gated channels: GABA-A receptor (Cl- channel) targeted by benzodiazepines (diazepam, lorazepam) and barbiturates. Nicotinic acetylcholine receptor (Na+/K+ channel) targeted by smoking cessation drug varenicline (Chantix). NMDA receptor (Ca2+ channel) targeted by anesthetic ketamine and Alzheimer's drug memantine.</a:t>
-            </a:r>
-          </a:p>
-          <a:p/>
-          <a:p>
-            <a:r>
-              <a:t>=== THE HODGKIN-HUXLEY MODEL (1952) ===</a:t>
-            </a:r>
-          </a:p>
-          <a:p>
-            <a:r>
-              <a:t>Alan Hodgkin and Andrew Huxley published their mathematical model of the action potential in 1952 (Journal of Physiology 117:500-544), for which they won the 1963 Nobel Prize in Physiology or Medicine. This is THE foundational biophysical model.</a:t>
-            </a:r>
-          </a:p>
-          <a:p/>
-          <a:p>
-            <a:r>
-              <a:t>The model describes the membrane potential V as:</a:t>
-            </a:r>
-          </a:p>
-          <a:p>
-            <a:r>
-              <a:t>  C_m * dV/dt = -g_Na * m^3 * h * (V - E_Na) - g_K * n^4 * (V - E_K) - g_L * (V - E_L) + I_ext</a:t>
-            </a:r>
-          </a:p>
-          <a:p/>
-          <a:p>
-            <a:r>
-              <a:t>Where:</a:t>
-            </a:r>
-          </a:p>
-          <a:p>
-            <a:r>
-              <a:t>- C_m = membrane capacitance (~1 uF/cm2)</a:t>
-            </a:r>
-          </a:p>
-          <a:p>
-            <a:r>
-              <a:t>- g_Na, g_K, g_L = maximum conductances for sodium, potassium, and leak channels</a:t>
-            </a:r>
-          </a:p>
-          <a:p>
-            <a:r>
-              <a:t>- m, h, n = gating variables (0 to 1) that describe channel opening/closing probability</a:t>
-            </a:r>
-          </a:p>
-          <a:p>
-            <a:r>
-              <a:t>- E_Na, E_K, E_L = reversal (Nernst) potentials for each ion</a:t>
-            </a:r>
-          </a:p>
-          <a:p>
-            <a:r>
-              <a:t>- I_ext = external stimulation current</a:t>
-            </a:r>
-          </a:p>
-          <a:p/>
-          <a:p>
-            <a:r>
-              <a:t>The gating variables m, h, n each follow first-order kinetics: dx/dt = alpha_x(V)*(1-x) - beta_x(V)*x, where alpha and beta are voltage-dependent rate constants. Drug effects can be modeled by modifying these parameters: a Na+ channel blocker reduces g_Na, a K+ channel blocker reduces g_K.</a:t>
-            </a:r>
-          </a:p>
-          <a:p/>
-          <a:p>
-            <a:r>
-              <a:t>In the Week 1 practical notebook, students will simulate the Hodgkin-Huxley model and see how modifying conductances (simulating drug effects) changes firing patterns. This directly connects to the SpikerBot observations.</a:t>
-            </a:r>
-          </a:p>
-          <a:p/>
-          <a:p>
-            <a:r>
-              <a:t>=== HUMAN PHYSIOLOGY EXPERIMENTS ===</a:t>
-            </a:r>
-          </a:p>
-          <a:p>
-            <a:r>
-              <a:t>Students can use the SpikerBot / Muscle SpikerShield to record their OWN signals:</a:t>
-            </a:r>
-          </a:p>
-          <a:p>
-            <a:r>
-              <a:t>- EMG (electromyography): Record muscle electrical activity from the forearm. Observe motor unit recruitment. Compare grip strength to EMG amplitude.</a:t>
-            </a:r>
-          </a:p>
-          <a:p>
-            <a:r>
-              <a:t>- ECG (electrocardiography): Record heart rhythm. Identify P, QRS, T waves. Measure heart rate variability.</a:t>
-            </a:r>
-          </a:p>
-          <a:p>
-            <a:r>
-              <a:t>- Grip force experiments: Measure how stimulation frequency affects force (the SpikerBot can stimulate and record).</a:t>
-            </a:r>
-          </a:p>
-          <a:p/>
-          <a:p>
-            <a:r>
-              <a:t>The computational pipeline is IDENTICAL to drug discovery:</a:t>
-            </a:r>
-          </a:p>
-          <a:p>
-            <a:r>
-              <a:t>  Biological signal -&gt; digitize -&gt; extract features -&gt; build ML model -&gt; predict</a:t>
-            </a:r>
-          </a:p>
-          <a:p>
-            <a:r>
-              <a:t>  Molecular structure -&gt; fingerprint -&gt; extract features -&gt; build ML model -&gt; predict</a:t>
-            </a:r>
-          </a:p>
-          <a:p/>
-          <a:p>
-            <a:r>
-              <a:t>This parallel is the key teaching point: the same ML methods work across domains.</a:t>
+              <a:t>=== CONNECTOMICS ===</a:t>
+            </a:r>
+          </a:p>
+          <a:p>
+            <a:r>
+              <a:t>The complete Drosophila brain connectome (FlyWire: Dorkenwald et al. 2024, Nature) is a graph with ~140,000 neurons and ~50 million synapses. This is THE dataset for Week 4's GNN concepts: neurons are nodes, synapses are edges, and GNNs can predict neuron types and function from graph structure.</a:t>
             </a:r>
           </a:p>
         </p:txBody>
@@ -1457,7 +1877,7 @@
           <a:lstStyle/>
           <a:p>
             <a:r>
-              <a:t>Quickly recap each point in 2-3 minutes. Emphasize the overarching narrative: drug discovery has a problem (slow/expensive/risky), AI is the solution, and this course will give students the tools to contribute. Remind students about the practical notebook.</a:t>
+              <a:t>Quickly recap each point in 2-3 minutes. Emphasize the overarching narrative: drug discovery has a problem (slow/expensive/risky), neuroscience provides critical target knowledge, AI is the tool to accelerate both fields, and this course bridges them. The GluCl example perfectly illustrates how basic neuroscience research (Drosophila visual circuits) connects to real-world drugs (ivermectin).</a:t>
             </a:r>
           </a:p>
         </p:txBody>
@@ -1807,7 +2227,56 @@
           <a:lstStyle/>
           <a:p>
             <a:r>
-              <a:t>Spend 3-4 minutes here. The left column shows aggregate statistics from Kola &amp; Landis (2004, Nature Reviews Drug Discovery). On the right, give brief stories: Vioxx was a blockbuster painkiller withdrawn after ~88,000 estimated cardiac events. Torcetrapib raised HDL cholesterol as intended but also raised blood pressure, $800M lost. These failures are not just financial, they affect patients. This is WHY we need better predictive tools. Ask students: can you think of other drug safety scandals? Transition: Now let me tell you an inspiring story.</a:t>
+              <a:t>Spend 3-4 minutes here. The left column shows aggregate statistics from Kola &amp; Landis (2004, Nature Reviews Drug Discovery).</a:t>
+            </a:r>
+          </a:p>
+          <a:p/>
+          <a:p>
+            <a:r>
+              <a:t>=== NEUROSCIENCE CONNECTION ===</a:t>
+            </a:r>
+          </a:p>
+          <a:p>
+            <a:r>
+              <a:t>CNS (central nervous system) drugs have the HIGHEST failure rate of any therapeutic area. Alzheimer's disease is the most dramatic example: Cummings et al. (2014, Alzheimer's Research &amp; Therapy 6:37) found a 99.6% failure rate for Alzheimer's drugs between 2002-2012. Only memantine (NMDA receptor antagonist) was approved in that decade.</a:t>
+            </a:r>
+          </a:p>
+          <a:p/>
+          <a:p>
+            <a:r>
+              <a:t>Why do CNS drugs fail so much?</a:t>
+            </a:r>
+          </a:p>
+          <a:p>
+            <a:r>
+              <a:t>1. The blood-brain barrier (BBB) blocks most molecules from reaching brain targets. A drug must be lipophilic enough to cross the BBB but not so lipophilic that it accumulates in fat tissue.</a:t>
+            </a:r>
+          </a:p>
+          <a:p>
+            <a:r>
+              <a:t>2. Brain targets are complex: GPCRs, ion channels, and transporters often have many subtypes. Selectivity is hard.</a:t>
+            </a:r>
+          </a:p>
+          <a:p>
+            <a:r>
+              <a:t>3. Animal models poorly predict human CNS drug response. A mouse brain is not a human brain.</a:t>
+            </a:r>
+          </a:p>
+          <a:p>
+            <a:r>
+              <a:t>4. Biomarkers for CNS diseases (Alzheimer's, Parkinson's, depression) are limited, making it hard to measure efficacy early.</a:t>
+            </a:r>
+          </a:p>
+          <a:p/>
+          <a:p>
+            <a:r>
+              <a:t>BIA 10-2474 is a chilling example: a FAAH (fatty acid amide hydrolase) inhibitor being tested for pain and mood disorders. In a Phase I trial in Rennes, France (2016), one healthy volunteer died and five were hospitalized with brain damage. FAAH breaks down endocannabinoids in the brain. The drug likely had off-target effects on other lipases in the brain. This underscores why understanding neuroscience targets deeply is critical for drug safety.</a:t>
+            </a:r>
+          </a:p>
+          <a:p/>
+          <a:p>
+            <a:r>
+              <a:t>The Drosophila connection: fruit fly neuroscience research helps us understand fundamental neural signaling mechanisms (ion channels, neurotransmitter receptors) that are drug targets in humans. Dr. Serbe-Kamp's work on GluClα channels in the fly visual system directly relates to the GluCl family that is targeted by ivermectin, one of the most important drugs in history.</a:t>
             </a:r>
           </a:p>
         </p:txBody>
@@ -2017,7 +2486,68 @@
           <a:lstStyle/>
           <a:p>
             <a:r>
-              <a:t>Spend 4-5 minutes on this slide. Go through each bullet with a real example. Virtual screening: BenevolentAI used AI to identify baricitinib as a potential COVID-19 treatment in Feb 2020, later validated in clinical trials and received FDA emergency use authorization. Lead optimization: Relay Therapeutics uses molecular dynamics + ML. De novo design: Insilico Medicine designed a novel drug candidate from scratch using AI. Clinical trials: Unlearn.AI creates digital twins to reduce control group sizes. AI does not replace wet-lab experiments, it prioritizes them.</a:t>
+              <a:t>Spend 4-5 minutes on this slide. Go through each bullet with examples, and highlight the neuroscience connection wherever possible.</a:t>
+            </a:r>
+          </a:p>
+          <a:p/>
+          <a:p>
+            <a:r>
+              <a:t>=== NEUROSCIENCE-SPECIFIC AI APPLICATIONS ===</a:t>
+            </a:r>
+          </a:p>
+          <a:p/>
+          <a:p>
+            <a:r>
+              <a:t>1. TARGET IDENTIFICATION from connectomics:</a:t>
+            </a:r>
+          </a:p>
+          <a:p>
+            <a:r>
+              <a:t>The complete Drosophila brain connectome (Dorkenwald et al. 2024, Nature) mapped ~140,000 neurons and ~50 million synapses. AI/ML is used to analyze this graph to identify cell types, predict function, and find potential drug targets. The same approach is being applied to the mouse brain connectome and will eventually reach human-scale. In Dr. Serbe-Kamp's research area, connectomics has been essential for mapping the visual motion detection circuit: identifying which neurons connect to T4/T5 motion-detecting cells and understanding the synaptic input patterns (Takemura et al. 2013, Nature; Shinomiya et al. 2019, eLife).</a:t>
+            </a:r>
+          </a:p>
+          <a:p/>
+          <a:p>
+            <a:r>
+              <a:t>2. VIRTUAL SCREENING for CNS drugs:</a:t>
+            </a:r>
+          </a:p>
+          <a:p>
+            <a:r>
+              <a:t>Screening compounds for blood-brain barrier penetration is a critical step for CNS drugs. AI models predict BBB permeability from molecular features. DeepBBB (Shaker et al. 2021) uses deep learning. This saves enormous time vs. experimental permeability assays.</a:t>
+            </a:r>
+          </a:p>
+          <a:p/>
+          <a:p>
+            <a:r>
+              <a:t>3. LEAD OPTIMIZATION for ion channel drugs:</a:t>
+            </a:r>
+          </a:p>
+          <a:p>
+            <a:r>
+              <a:t>Many drugs target ion channels that are central to neuroscience: Nav channels (anti-epileptics), GABA-A (anxiolytics), nAChR (nicotine addiction). AI can predict selectivity between channel subtypes, which is crucial to avoid side effects.</a:t>
+            </a:r>
+          </a:p>
+          <a:p/>
+          <a:p>
+            <a:r>
+              <a:t>4. REPURPOSING with neuroscience insights:</a:t>
+            </a:r>
+          </a:p>
+          <a:p>
+            <a:r>
+              <a:t>Ivermectin was originally an antiparasitic drug (targets GluCl channels in parasites). It is now being investigated for anticancer properties and has shown activity against various cancers in preclinical studies. BenevolentAI identified baricitinib (a JAK inhibitor) for COVID-19 in Feb 2020. Repurposing leverages existing safety data to fast-track drugs.</a:t>
+            </a:r>
+          </a:p>
+          <a:p/>
+          <a:p>
+            <a:r>
+              <a:t>5. CONNECTOMICS + AI:</a:t>
+            </a:r>
+          </a:p>
+          <a:p>
+            <a:r>
+              <a:t>The Drosophila connectome is a GRAPH with neurons as nodes and synapses as edges. Graph neural networks (which we will study in Week 4) can be directly applied to this data. Zeng et al. (2023, Cell Reports Methods) used GNNs on connectomics data to predict neuron types and circuit function.</a:t>
             </a:r>
           </a:p>
         </p:txBody>
@@ -5408,36 +5938,36 @@
               </a:defRPr>
             </a:pPr>
             <a:r>
-              <a:t>Jumper et al. (2021), Nature - most-cited paper of the decade</a:t>
-            </a:r>
-          </a:p>
-          <a:p>
-            <a:pPr>
-              <a:spcAft>
-                <a:spcPts val="800"/>
-              </a:spcAft>
-              <a:defRPr sz="2000">
-                <a:solidFill>
-                  <a:srgbClr val="323232"/>
-                </a:solidFill>
-                <a:latin typeface="Calibri"/>
-              </a:defRPr>
-            </a:pPr>
-          </a:p>
-          <a:p>
-            <a:pPr>
-              <a:spcAft>
-                <a:spcPts val="800"/>
-              </a:spcAft>
-              <a:defRPr sz="2000">
-                <a:solidFill>
-                  <a:srgbClr val="323232"/>
-                </a:solidFill>
-                <a:latin typeface="Calibri"/>
-              </a:defRPr>
-            </a:pPr>
-            <a:r>
-              <a:t>Impact on drug discovery:</a:t>
+              <a:t>Jumper et al. (2021), Nature - 2024 Nobel Prize in Chemistry</a:t>
+            </a:r>
+          </a:p>
+          <a:p>
+            <a:pPr>
+              <a:spcAft>
+                <a:spcPts val="800"/>
+              </a:spcAft>
+              <a:defRPr sz="2000">
+                <a:solidFill>
+                  <a:srgbClr val="323232"/>
+                </a:solidFill>
+                <a:latin typeface="Calibri"/>
+              </a:defRPr>
+            </a:pPr>
+          </a:p>
+          <a:p>
+            <a:pPr>
+              <a:spcAft>
+                <a:spcPts val="800"/>
+              </a:spcAft>
+              <a:defRPr sz="2000">
+                <a:solidFill>
+                  <a:srgbClr val="323232"/>
+                </a:solidFill>
+                <a:latin typeface="Calibri"/>
+              </a:defRPr>
+            </a:pPr>
+            <a:r>
+              <a:t>Impact on drug discovery &amp; neuroscience:</a:t>
             </a:r>
           </a:p>
           <a:p>
@@ -5469,23 +5999,23 @@
               </a:defRPr>
             </a:pPr>
             <a:r>
-              <a:t>  Structure-based drug design now possible for undruggable targets</a:t>
-            </a:r>
-          </a:p>
-          <a:p>
-            <a:pPr>
-              <a:spcAft>
-                <a:spcPts val="800"/>
-              </a:spcAft>
-              <a:defRPr sz="2000">
-                <a:solidFill>
-                  <a:srgbClr val="323232"/>
-                </a:solidFill>
-                <a:latin typeface="Calibri"/>
-              </a:defRPr>
-            </a:pPr>
-            <a:r>
-              <a:t>  Faster understanding of disease mechanisms</a:t>
+              <a:t>  Ion channels, GPCRs, neurotransmitter receptors now have predicted structures</a:t>
+            </a:r>
+          </a:p>
+          <a:p>
+            <a:pPr>
+              <a:spcAft>
+                <a:spcPts val="800"/>
+              </a:spcAft>
+              <a:defRPr sz="2000">
+                <a:solidFill>
+                  <a:srgbClr val="323232"/>
+                </a:solidFill>
+                <a:latin typeface="Calibri"/>
+              </a:defRPr>
+            </a:pPr>
+            <a:r>
+              <a:t>  Structure-based drug design for CNS targets (hERG, GABA-A, GluCl, nAChR)</a:t>
             </a:r>
           </a:p>
           <a:p>
@@ -5530,7 +6060,23 @@
               </a:defRPr>
             </a:pPr>
             <a:r>
-              <a:t>Isomorphic Labs (DeepMind spin-off) - applying this directly to drug design</a:t>
+              <a:t>Neuroscience example: AlphaFold predicted the GluCl receptor structure</a:t>
+            </a:r>
+          </a:p>
+          <a:p>
+            <a:pPr>
+              <a:spcAft>
+                <a:spcPts val="800"/>
+              </a:spcAft>
+              <a:defRPr sz="2000">
+                <a:solidFill>
+                  <a:srgbClr val="323232"/>
+                </a:solidFill>
+                <a:latin typeface="Calibri"/>
+              </a:defRPr>
+            </a:pPr>
+            <a:r>
+              <a:t>  (same channel family Dr. Serbe-Kamp studies in Drosophila motion vision!)</a:t>
             </a:r>
           </a:p>
         </p:txBody>
@@ -5881,87 +6427,103 @@
               </a:defRPr>
             </a:pPr>
             <a:r>
-              <a:t>Examples:</a:t>
-            </a:r>
-          </a:p>
-          <a:p>
-            <a:pPr>
-              <a:spcAft>
-                <a:spcPts val="800"/>
-              </a:spcAft>
-              <a:defRPr sz="2000">
-                <a:solidFill>
-                  <a:srgbClr val="323232"/>
-                </a:solidFill>
-                <a:latin typeface="Calibri"/>
-              </a:defRPr>
-            </a:pPr>
-            <a:r>
-              <a:t>  Water: O</a:t>
-            </a:r>
-          </a:p>
-          <a:p>
-            <a:pPr>
-              <a:spcAft>
-                <a:spcPts val="800"/>
-              </a:spcAft>
-              <a:defRPr sz="2000">
-                <a:solidFill>
-                  <a:srgbClr val="323232"/>
-                </a:solidFill>
-                <a:latin typeface="Calibri"/>
-              </a:defRPr>
-            </a:pPr>
-            <a:r>
-              <a:t>  Ethanol: CCO</a:t>
-            </a:r>
-          </a:p>
-          <a:p>
-            <a:pPr>
-              <a:spcAft>
-                <a:spcPts val="800"/>
-              </a:spcAft>
-              <a:defRPr sz="2000">
-                <a:solidFill>
-                  <a:srgbClr val="323232"/>
-                </a:solidFill>
-                <a:latin typeface="Calibri"/>
-              </a:defRPr>
-            </a:pPr>
-            <a:r>
-              <a:t>  Aspirin: CC(=O)Oc1ccccc1C(=O)O</a:t>
-            </a:r>
-          </a:p>
-          <a:p>
-            <a:pPr>
-              <a:spcAft>
-                <a:spcPts val="800"/>
-              </a:spcAft>
-              <a:defRPr sz="2000">
-                <a:solidFill>
-                  <a:srgbClr val="323232"/>
-                </a:solidFill>
-                <a:latin typeface="Calibri"/>
-              </a:defRPr>
-            </a:pPr>
-            <a:r>
-              <a:t>  Caffeine: Cn1c(=O)c2c(ncn2C)n(C)c1=O</a:t>
-            </a:r>
-          </a:p>
-          <a:p>
-            <a:pPr>
-              <a:spcAft>
-                <a:spcPts val="800"/>
-              </a:spcAft>
-              <a:defRPr sz="2000">
-                <a:solidFill>
-                  <a:srgbClr val="323232"/>
-                </a:solidFill>
-                <a:latin typeface="Calibri"/>
-              </a:defRPr>
-            </a:pPr>
-            <a:r>
-              <a:t>  Ibuprofen: CC(C)Cc1ccc(cc1)C(C)C(=O)O</a:t>
+              <a:t>Examples (including neuroscience drugs):</a:t>
+            </a:r>
+          </a:p>
+          <a:p>
+            <a:pPr>
+              <a:spcAft>
+                <a:spcPts val="800"/>
+              </a:spcAft>
+              <a:defRPr sz="2000">
+                <a:solidFill>
+                  <a:srgbClr val="323232"/>
+                </a:solidFill>
+                <a:latin typeface="Calibri"/>
+              </a:defRPr>
+            </a:pPr>
+            <a:r>
+              <a:t>  Water: O  |  Ethanol: CCO  |  Aspirin: CC(=O)Oc1ccccc1C(=O)O</a:t>
+            </a:r>
+          </a:p>
+          <a:p>
+            <a:pPr>
+              <a:spcAft>
+                <a:spcPts val="800"/>
+              </a:spcAft>
+              <a:defRPr sz="2000">
+                <a:solidFill>
+                  <a:srgbClr val="323232"/>
+                </a:solidFill>
+                <a:latin typeface="Calibri"/>
+              </a:defRPr>
+            </a:pPr>
+            <a:r>
+              <a:t>  Caffeine: Cn1c(=O)c2c(ncn2C)n(C)c1=O  (adenosine receptor antagonist)</a:t>
+            </a:r>
+          </a:p>
+          <a:p>
+            <a:pPr>
+              <a:spcAft>
+                <a:spcPts val="800"/>
+              </a:spcAft>
+              <a:defRPr sz="2000">
+                <a:solidFill>
+                  <a:srgbClr val="323232"/>
+                </a:solidFill>
+                <a:latin typeface="Calibri"/>
+              </a:defRPr>
+            </a:pPr>
+            <a:r>
+              <a:t>  Serotonin: NCCc1c[nH]c2ccc(O)cc12  (neurotransmitter)</a:t>
+            </a:r>
+          </a:p>
+          <a:p>
+            <a:pPr>
+              <a:spcAft>
+                <a:spcPts val="800"/>
+              </a:spcAft>
+              <a:defRPr sz="2000">
+                <a:solidFill>
+                  <a:srgbClr val="323232"/>
+                </a:solidFill>
+                <a:latin typeface="Calibri"/>
+              </a:defRPr>
+            </a:pPr>
+            <a:r>
+              <a:t>  Dopamine: NCCc1ccc(O)c(O)c1  (neurotransmitter)</a:t>
+            </a:r>
+          </a:p>
+          <a:p>
+            <a:pPr>
+              <a:spcAft>
+                <a:spcPts val="800"/>
+              </a:spcAft>
+              <a:defRPr sz="2000">
+                <a:solidFill>
+                  <a:srgbClr val="323232"/>
+                </a:solidFill>
+                <a:latin typeface="Calibri"/>
+              </a:defRPr>
+            </a:pPr>
+            <a:r>
+              <a:t>  GABA: NCCCC(=O)O  (inhibitory neurotransmitter)</a:t>
+            </a:r>
+          </a:p>
+          <a:p>
+            <a:pPr>
+              <a:spcAft>
+                <a:spcPts val="800"/>
+              </a:spcAft>
+              <a:defRPr sz="2000">
+                <a:solidFill>
+                  <a:srgbClr val="323232"/>
+                </a:solidFill>
+                <a:latin typeface="Calibri"/>
+              </a:defRPr>
+            </a:pPr>
+            <a:r>
+              <a:t>  Diazepam (Valium): ClC1=CC2=C(C=C1)N(C)C(=O)CN2  (GABA-A modulator)</a:t>
             </a:r>
           </a:p>
           <a:p>
@@ -6223,100 +6785,116 @@
               </a:defRPr>
             </a:pPr>
             <a:r>
-              <a:t>  IC50 - Concentration that inhibits 50% of target activity</a:t>
-            </a:r>
-          </a:p>
-          <a:p>
-            <a:pPr>
-              <a:spcAft>
-                <a:spcPts val="800"/>
-              </a:spcAft>
-              <a:defRPr sz="2000">
-                <a:solidFill>
-                  <a:srgbClr val="323232"/>
-                </a:solidFill>
-                <a:latin typeface="Calibri"/>
-              </a:defRPr>
-            </a:pPr>
-            <a:r>
-              <a:t>  Ki - Binding affinity constant (inhibition constant)</a:t>
-            </a:r>
-          </a:p>
-          <a:p>
-            <a:pPr>
-              <a:spcAft>
-                <a:spcPts val="800"/>
-              </a:spcAft>
-              <a:defRPr sz="2000">
-                <a:solidFill>
-                  <a:srgbClr val="323232"/>
-                </a:solidFill>
-                <a:latin typeface="Calibri"/>
-              </a:defRPr>
-            </a:pPr>
-            <a:r>
-              <a:t>  EC50 - Concentration that produces 50% of maximum effect</a:t>
-            </a:r>
-          </a:p>
-          <a:p>
-            <a:pPr>
-              <a:spcAft>
-                <a:spcPts val="800"/>
-              </a:spcAft>
-              <a:defRPr sz="2000">
-                <a:solidFill>
-                  <a:srgbClr val="323232"/>
-                </a:solidFill>
-                <a:latin typeface="Calibri"/>
-              </a:defRPr>
-            </a:pPr>
-            <a:r>
-              <a:t>  Kd - Dissociation constant (binding strength)</a:t>
-            </a:r>
-          </a:p>
-          <a:p>
-            <a:pPr>
-              <a:spcAft>
-                <a:spcPts val="800"/>
-              </a:spcAft>
-              <a:defRPr sz="2000">
-                <a:solidFill>
-                  <a:srgbClr val="323232"/>
-                </a:solidFill>
-                <a:latin typeface="Calibri"/>
-              </a:defRPr>
-            </a:pPr>
-          </a:p>
-          <a:p>
-            <a:pPr>
-              <a:spcAft>
-                <a:spcPts val="800"/>
-              </a:spcAft>
-              <a:defRPr sz="2000">
-                <a:solidFill>
-                  <a:srgbClr val="323232"/>
-                </a:solidFill>
-                <a:latin typeface="Calibri"/>
-              </a:defRPr>
-            </a:pPr>
-            <a:r>
-              <a:t>Typically reported as pIC50 = -log10(IC50) for easier modeling</a:t>
-            </a:r>
-          </a:p>
-          <a:p>
-            <a:pPr>
-              <a:spcAft>
-                <a:spcPts val="800"/>
-              </a:spcAft>
-              <a:defRPr sz="2000">
-                <a:solidFill>
-                  <a:srgbClr val="323232"/>
-                </a:solidFill>
-                <a:latin typeface="Calibri"/>
-              </a:defRPr>
-            </a:pPr>
-            <a:r>
-              <a:t>Higher pIC50 = more potent compound</a:t>
+              <a:t>  IC50 - Concentration inhibiting 50% of target activity</a:t>
+            </a:r>
+          </a:p>
+          <a:p>
+            <a:pPr>
+              <a:spcAft>
+                <a:spcPts val="800"/>
+              </a:spcAft>
+              <a:defRPr sz="2000">
+                <a:solidFill>
+                  <a:srgbClr val="323232"/>
+                </a:solidFill>
+                <a:latin typeface="Calibri"/>
+              </a:defRPr>
+            </a:pPr>
+            <a:r>
+              <a:t>  Ki - Binding affinity constant  |  EC50 - Half-maximal effective concentration</a:t>
+            </a:r>
+          </a:p>
+          <a:p>
+            <a:pPr>
+              <a:spcAft>
+                <a:spcPts val="800"/>
+              </a:spcAft>
+              <a:defRPr sz="2000">
+                <a:solidFill>
+                  <a:srgbClr val="323232"/>
+                </a:solidFill>
+                <a:latin typeface="Calibri"/>
+              </a:defRPr>
+            </a:pPr>
+            <a:r>
+              <a:t>  Kd - Dissociation constant  |  pIC50 = -log10(IC50) for easier modeling</a:t>
+            </a:r>
+          </a:p>
+          <a:p>
+            <a:pPr>
+              <a:spcAft>
+                <a:spcPts val="800"/>
+              </a:spcAft>
+              <a:defRPr sz="2000">
+                <a:solidFill>
+                  <a:srgbClr val="323232"/>
+                </a:solidFill>
+                <a:latin typeface="Calibri"/>
+              </a:defRPr>
+            </a:pPr>
+          </a:p>
+          <a:p>
+            <a:pPr>
+              <a:spcAft>
+                <a:spcPts val="800"/>
+              </a:spcAft>
+              <a:defRPr sz="2000">
+                <a:solidFill>
+                  <a:srgbClr val="323232"/>
+                </a:solidFill>
+                <a:latin typeface="Calibri"/>
+              </a:defRPr>
+            </a:pPr>
+            <a:r>
+              <a:t>Neuroscience assay examples:</a:t>
+            </a:r>
+          </a:p>
+          <a:p>
+            <a:pPr>
+              <a:spcAft>
+                <a:spcPts val="800"/>
+              </a:spcAft>
+              <a:defRPr sz="2000">
+                <a:solidFill>
+                  <a:srgbClr val="323232"/>
+                </a:solidFill>
+                <a:latin typeface="Calibri"/>
+              </a:defRPr>
+            </a:pPr>
+            <a:r>
+              <a:t>  Patch-clamp electrophysiology: measure ion channel block (IC50 for hERG)</a:t>
+            </a:r>
+          </a:p>
+          <a:p>
+            <a:pPr>
+              <a:spcAft>
+                <a:spcPts val="800"/>
+              </a:spcAft>
+              <a:defRPr sz="2000">
+                <a:solidFill>
+                  <a:srgbClr val="323232"/>
+                </a:solidFill>
+                <a:latin typeface="Calibri"/>
+              </a:defRPr>
+            </a:pPr>
+            <a:r>
+              <a:t>  Calcium imaging: measure receptor activation (EC50 for GPCR agonists)</a:t>
+            </a:r>
+          </a:p>
+          <a:p>
+            <a:pPr>
+              <a:spcAft>
+                <a:spcPts val="800"/>
+              </a:spcAft>
+              <a:defRPr sz="2000">
+                <a:solidFill>
+                  <a:srgbClr val="323232"/>
+                </a:solidFill>
+                <a:latin typeface="Calibri"/>
+              </a:defRPr>
+            </a:pPr>
+            <a:r>
+              <a:t>  Radioligand binding: measure receptor affinity (Ki for dopamine D2)</a:t>
             </a:r>
           </a:p>
           <a:p>
@@ -6960,7 +7538,7 @@
               </a:defRPr>
             </a:pPr>
             <a:r>
-              <a:t>  Marzullo et al. (2012), Advances in Physiology Education 36:2-14</a:t>
+              <a:t>  Dr. Serbe-Kamp is Co-Director of Summer Fellowships at Backyard Brains</a:t>
             </a:r>
           </a:p>
           <a:p>
@@ -7005,7 +7583,7 @@
               </a:defRPr>
             </a:pPr>
             <a:r>
-              <a:t>  Tonic firing - regular spikes (motor neurons, pacemaker cells)</a:t>
+              <a:t>  Tonic firing - regular spikes (motor neurons, Drosophila visual interneurons)</a:t>
             </a:r>
           </a:p>
           <a:p>
@@ -7066,84 +7644,100 @@
               </a:defRPr>
             </a:pPr>
             <a:r>
-              <a:t>Neuropharmacology connection:</a:t>
-            </a:r>
-          </a:p>
-          <a:p>
-            <a:pPr>
-              <a:spcAft>
-                <a:spcPts val="800"/>
-              </a:spcAft>
-              <a:defRPr sz="2000">
-                <a:solidFill>
-                  <a:srgbClr val="323232"/>
-                </a:solidFill>
-                <a:latin typeface="Calibri"/>
-              </a:defRPr>
-            </a:pPr>
-            <a:r>
-              <a:t>  Ion channels (Na+, K+, Ca2+) are major drug targets (~18% of approved drugs)</a:t>
-            </a:r>
-          </a:p>
-          <a:p>
-            <a:pPr>
-              <a:spcAft>
-                <a:spcPts val="800"/>
-              </a:spcAft>
-              <a:defRPr sz="2000">
-                <a:solidFill>
-                  <a:srgbClr val="323232"/>
-                </a:solidFill>
-                <a:latin typeface="Calibri"/>
-              </a:defRPr>
-            </a:pPr>
-            <a:r>
-              <a:t>  The Hodgkin-Huxley model (1952) describes how drugs alter channel gating</a:t>
-            </a:r>
-          </a:p>
-          <a:p>
-            <a:pPr>
-              <a:spcAft>
-                <a:spcPts val="800"/>
-              </a:spcAft>
-              <a:defRPr sz="2000">
-                <a:solidFill>
-                  <a:srgbClr val="323232"/>
-                </a:solidFill>
-                <a:latin typeface="Calibri"/>
-              </a:defRPr>
-            </a:pPr>
-            <a:r>
-              <a:t>  hERG (K+ channel) block -&gt; cardiac arrhythmia, #1 reason drugs are withdrawn</a:t>
-            </a:r>
-          </a:p>
-          <a:p>
-            <a:pPr>
-              <a:spcAft>
-                <a:spcPts val="800"/>
-              </a:spcAft>
-              <a:defRPr sz="2000">
-                <a:solidFill>
-                  <a:srgbClr val="323232"/>
-                </a:solidFill>
-                <a:latin typeface="Calibri"/>
-              </a:defRPr>
-            </a:pPr>
-          </a:p>
-          <a:p>
-            <a:pPr>
-              <a:spcAft>
-                <a:spcPts val="800"/>
-              </a:spcAft>
-              <a:defRPr sz="2000">
-                <a:solidFill>
-                  <a:srgbClr val="323232"/>
-                </a:solidFill>
-                <a:latin typeface="Calibri"/>
-              </a:defRPr>
-            </a:pPr>
-            <a:r>
-              <a:t>Same pipeline: biological signal -&gt; digitize -&gt; features -&gt; ML model</a:t>
+              <a:t>From Drosophila to drug discovery:</a:t>
+            </a:r>
+          </a:p>
+          <a:p>
+            <a:pPr>
+              <a:spcAft>
+                <a:spcPts val="800"/>
+              </a:spcAft>
+              <a:defRPr sz="2000">
+                <a:solidFill>
+                  <a:srgbClr val="323232"/>
+                </a:solidFill>
+                <a:latin typeface="Calibri"/>
+              </a:defRPr>
+            </a:pPr>
+            <a:r>
+              <a:t>  Ion channels (Na+, K+, Ca2+, Cl-) are major drug targets (~18% of drugs)</a:t>
+            </a:r>
+          </a:p>
+          <a:p>
+            <a:pPr>
+              <a:spcAft>
+                <a:spcPts val="800"/>
+              </a:spcAft>
+              <a:defRPr sz="2000">
+                <a:solidFill>
+                  <a:srgbClr val="323232"/>
+                </a:solidFill>
+                <a:latin typeface="Calibri"/>
+              </a:defRPr>
+            </a:pPr>
+            <a:r>
+              <a:t>  GluCl channels (from Dr. Serbe-Kamp's fly research) = ivermectin target!</a:t>
+            </a:r>
+          </a:p>
+          <a:p>
+            <a:pPr>
+              <a:spcAft>
+                <a:spcPts val="800"/>
+              </a:spcAft>
+              <a:defRPr sz="2000">
+                <a:solidFill>
+                  <a:srgbClr val="323232"/>
+                </a:solidFill>
+                <a:latin typeface="Calibri"/>
+              </a:defRPr>
+            </a:pPr>
+            <a:r>
+              <a:t>  Hodgkin-Huxley model (1952): simulate how drugs alter channel gating</a:t>
+            </a:r>
+          </a:p>
+          <a:p>
+            <a:pPr>
+              <a:spcAft>
+                <a:spcPts val="800"/>
+              </a:spcAft>
+              <a:defRPr sz="2000">
+                <a:solidFill>
+                  <a:srgbClr val="323232"/>
+                </a:solidFill>
+                <a:latin typeface="Calibri"/>
+              </a:defRPr>
+            </a:pPr>
+            <a:r>
+              <a:t>  Connectomics: map ALL synapses -&gt; identify new drug targets</a:t>
+            </a:r>
+          </a:p>
+          <a:p>
+            <a:pPr>
+              <a:spcAft>
+                <a:spcPts val="800"/>
+              </a:spcAft>
+              <a:defRPr sz="2000">
+                <a:solidFill>
+                  <a:srgbClr val="323232"/>
+                </a:solidFill>
+                <a:latin typeface="Calibri"/>
+              </a:defRPr>
+            </a:pPr>
+          </a:p>
+          <a:p>
+            <a:pPr>
+              <a:spcAft>
+                <a:spcPts val="800"/>
+              </a:spcAft>
+              <a:defRPr sz="2000">
+                <a:solidFill>
+                  <a:srgbClr val="323232"/>
+                </a:solidFill>
+                <a:latin typeface="Calibri"/>
+              </a:defRPr>
+            </a:pPr>
+            <a:r>
+              <a:t>Same pipeline: neural signal -&gt; features -&gt; ML model -&gt; prediction</a:t>
             </a:r>
           </a:p>
         </p:txBody>
@@ -8189,6 +8783,22 @@
               </a:defRPr>
             </a:pPr>
             <a:r>
+              <a:t>CNS drugs fail most: 99.6% failure rate for Alzheimer's drugs (2002-2012)</a:t>
+            </a:r>
+          </a:p>
+          <a:p>
+            <a:pPr>
+              <a:spcAft>
+                <a:spcPts val="800"/>
+              </a:spcAft>
+              <a:defRPr sz="2200">
+                <a:solidFill>
+                  <a:srgbClr val="FFFFFF"/>
+                </a:solidFill>
+                <a:latin typeface="Calibri"/>
+              </a:defRPr>
+            </a:pPr>
+            <a:r>
               <a:t>AI can accelerate every stage - from target ID to clinical trials</a:t>
             </a:r>
           </a:p>
@@ -8205,7 +8815,7 @@
               </a:defRPr>
             </a:pPr>
             <a:r>
-              <a:t>Real examples: Insilico Medicine, AlphaFold, BenevolentAI</a:t>
+              <a:t>Real examples: Insilico Medicine, AlphaFold, Drosophila connectomics</a:t>
             </a:r>
           </a:p>
           <a:p>
@@ -8221,7 +8831,7 @@
               </a:defRPr>
             </a:pPr>
             <a:r>
-              <a:t>SMILES notation converts molecules into computer-readable text</a:t>
+              <a:t>SMILES notation converts molecules (incl. neurotransmitters) to text</a:t>
             </a:r>
           </a:p>
           <a:p>
@@ -8237,7 +8847,7 @@
               </a:defRPr>
             </a:pPr>
             <a:r>
-              <a:t>Bioactivity data (IC50, Ki) measures drug-target interactions</a:t>
+              <a:t>Bioactivity data (IC50, Ki) comes from assays like patch-clamp &amp; calcium imaging</a:t>
             </a:r>
           </a:p>
           <a:p>
@@ -8253,7 +8863,7 @@
               </a:defRPr>
             </a:pPr>
             <a:r>
-              <a:t>RDKit is the essential Python toolkit for cheminformatics</a:t>
+              <a:t>Neuroscience &amp; drug discovery share the same pipeline: signal -&gt; features -&gt; ML</a:t>
             </a:r>
           </a:p>
           <a:p>
@@ -8269,23 +8879,7 @@
               </a:defRPr>
             </a:pPr>
             <a:r>
-              <a:t>The computational pipeline (signal -&gt; features -&gt; model) is universal</a:t>
-            </a:r>
-          </a:p>
-          <a:p>
-            <a:pPr>
-              <a:spcAft>
-                <a:spcPts val="800"/>
-              </a:spcAft>
-              <a:defRPr sz="2200">
-                <a:solidFill>
-                  <a:srgbClr val="FFFFFF"/>
-                </a:solidFill>
-                <a:latin typeface="Calibri"/>
-              </a:defRPr>
-            </a:pPr>
-            <a:r>
-              <a:t>Personalized medicine (mRNA vaccines) shows where we are heading</a:t>
+              <a:t>GluCl channels: from Drosophila motion vision to ivermectin drug target</a:t>
             </a:r>
           </a:p>
         </p:txBody>
@@ -9784,7 +10378,7 @@
               </a:defRPr>
             </a:pPr>
             <a:r>
-              <a:t>Infamous Failures</a:t>
+              <a:t>Infamous Failures (incl. CNS drugs)</a:t>
             </a:r>
           </a:p>
         </p:txBody>
@@ -9839,7 +10433,7 @@
               </a:defRPr>
             </a:pPr>
             <a:r>
-              <a:t>Thalidomide (1960s) - birth defects</a:t>
+              <a:t>Thalidomide (1960s) - birth defects (teratogenicity)</a:t>
             </a:r>
           </a:p>
           <a:p>
@@ -9855,7 +10449,7 @@
               </a:defRPr>
             </a:pPr>
             <a:r>
-              <a:t>BIA 10-2474 (2016) - Phase I death in France</a:t>
+              <a:t>BIA 10-2474 (2016) - Phase I death (FAAH inhibitor, CNS target)</a:t>
             </a:r>
           </a:p>
           <a:p>
@@ -9871,7 +10465,7 @@
               </a:defRPr>
             </a:pPr>
             <a:r>
-              <a:t>Pfizer torcetrapib - $800M Phase III failure</a:t>
+              <a:t>Eli Lilly semagacestat - worsened Alzheimer's symptoms</a:t>
             </a:r>
           </a:p>
           <a:p>
@@ -9887,7 +10481,7 @@
               </a:defRPr>
             </a:pPr>
             <a:r>
-              <a:t>Eli Lilly semagacestat - worsened Alzheimer's</a:t>
+              <a:t>~99.6% Alzheimer's drug candidates fail (Cummings et al. 2014)</a:t>
             </a:r>
           </a:p>
         </p:txBody>
@@ -10352,7 +10946,7 @@
               </a:defRPr>
             </a:pPr>
             <a:r>
-              <a:t>Target Identification - NLP on literature, network biology, multi-omics</a:t>
+              <a:t>Target Identification - NLP on literature, network biology, multi-omics, connectomics</a:t>
             </a:r>
           </a:p>
           <a:p>
@@ -10432,21 +11026,37 @@
               </a:defRPr>
             </a:pPr>
             <a:r>
-              <a:t>Repurposing - Find new uses for existing approved drugs (e.g., Baricitinib for COVID-19)</a:t>
-            </a:r>
-          </a:p>
-          <a:p>
-            <a:pPr>
-              <a:spcAft>
-                <a:spcPts val="800"/>
-              </a:spcAft>
-              <a:defRPr sz="2000">
-                <a:solidFill>
-                  <a:srgbClr val="323232"/>
-                </a:solidFill>
-                <a:latin typeface="Calibri"/>
-              </a:defRPr>
-            </a:pPr>
+              <a:t>Repurposing - Find new uses for existing drugs (e.g., ivermectin: antiparasitic -&gt; anticancer?)</a:t>
+            </a:r>
+          </a:p>
+          <a:p>
+            <a:pPr>
+              <a:spcAft>
+                <a:spcPts val="800"/>
+              </a:spcAft>
+              <a:defRPr sz="2000">
+                <a:solidFill>
+                  <a:srgbClr val="323232"/>
+                </a:solidFill>
+                <a:latin typeface="Calibri"/>
+              </a:defRPr>
+            </a:pPr>
+          </a:p>
+          <a:p>
+            <a:pPr>
+              <a:spcAft>
+                <a:spcPts val="800"/>
+              </a:spcAft>
+              <a:defRPr sz="2000">
+                <a:solidFill>
+                  <a:srgbClr val="323232"/>
+                </a:solidFill>
+                <a:latin typeface="Calibri"/>
+              </a:defRPr>
+            </a:pPr>
+            <a:r>
+              <a:t>Neuroscience example: AI on the Drosophila connectome identifies new neural targets</a:t>
+            </a:r>
           </a:p>
           <a:p>
             <a:pPr>

</xml_diff>